<commit_message>
Build full presentation content (slides 1-9, 13, 20-21) into MiNiFi_pilot.pptx
Adds title, recap (1-4), MiNiFi basics (5-6, updated to final English text), NiFi vs MiNiFi comparison table (7), AirPy rationale (8), PoC results table (9), Airflow REST API + code sample (13), Recommendation (20), Next Steps (21). Sections D (11-12,14-17) and E (18-19,22) remain pending in the outline.

Co-Authored-By: Claude Sonnet 5 <noreply@anthropic.com>
</commit_message>
<xml_diff>
--- a/MiNiFi_pilot.pptx
+++ b/MiNiFi_pilot.pptx
@@ -38,8 +38,18 @@
     <p:sldId id="283" r:id="rId26"/>
     <p:sldId id="284" r:id="rId27"/>
     <p:sldId id="285" r:id="rId28"/>
+    <p:sldId id="500" r:id="rId100"/>
+    <p:sldId id="501" r:id="rId101"/>
+    <p:sldId id="502" r:id="rId102"/>
+    <p:sldId id="503" r:id="rId103"/>
     <p:sldId id="401" r:id="rId29"/>
     <p:sldId id="402" r:id="rId30"/>
+    <p:sldId id="504" r:id="rId104"/>
+    <p:sldId id="505" r:id="rId105"/>
+    <p:sldId id="506" r:id="rId106"/>
+    <p:sldId id="507" r:id="rId107"/>
+    <p:sldId id="508" r:id="rId108"/>
+    <p:sldId id="509" r:id="rId109"/>
   </p:sldIdLst>
   <p:sldSz cx="12192000" cy="6858000"/>
   <p:notesSz cx="6858000" cy="9144000"/>
@@ -17227,6 +17237,2823 @@
 </p:sld>
 </file>
 
+<file path=ppt/slides/slide100.xml><?xml version="1.0" encoding="utf-8"?>
+<p:sld xmlns:a="http://schemas.openxmlformats.org/drawingml/2006/main" xmlns:r="http://schemas.openxmlformats.org/officeDocument/2006/relationships" xmlns:p="http://schemas.openxmlformats.org/presentationml/2006/main">
+  <p:cSld>
+    <p:spTree>
+      <p:nvGrpSpPr>
+        <p:cNvPr id="1" name=""/>
+        <p:cNvGrpSpPr/>
+        <p:nvPr/>
+      </p:nvGrpSpPr>
+      <p:grpSpPr>
+        <a:xfrm>
+          <a:off x="0" y="0"/>
+          <a:ext cx="0" cy="0"/>
+          <a:chOff x="0" y="0"/>
+          <a:chExt cx="0" cy="0"/>
+        </a:xfrm>
+      </p:grpSpPr>
+      <p:sp>
+        <p:nvSpPr>
+          <p:cNvPr id="2" name="Title Placeholder"/>
+          <p:cNvSpPr>
+            <a:spLocks noGrp="1"/>
+          </p:cNvSpPr>
+          <p:nvPr>
+            <p:ph type="body" sz="quarter" idx="12"/>
+          </p:nvPr>
+        </p:nvSpPr>
+        <p:spPr/>
+        <p:txBody>
+          <a:bodyPr/>
+          <a:lstStyle/>
+          <a:p>
+            <a:pPr lvl="0"/>
+            <a:r>
+              <a:rPr lang="en-GB" dirty="0"/>
+              <a:t>Ingest Tool for DataMesh</a:t>
+            </a:r>
+          </a:p>
+        </p:txBody>
+      </p:sp>
+      <p:sp>
+        <p:nvSpPr>
+          <p:cNvPr id="3" name="Subtitle Placeholder"/>
+          <p:cNvSpPr>
+            <a:spLocks noGrp="1"/>
+          </p:cNvSpPr>
+          <p:nvPr>
+            <p:ph type="body" sz="quarter" idx="14"/>
+          </p:nvPr>
+        </p:nvSpPr>
+        <p:spPr/>
+        <p:txBody>
+          <a:bodyPr/>
+          <a:lstStyle/>
+          <a:p>
+            <a:pPr lvl="0"/>
+            <a:r>
+              <a:rPr lang="en-GB" dirty="0"/>
+              <a:t>Recommended Architecture</a:t>
+            </a:r>
+          </a:p>
+        </p:txBody>
+      </p:sp>
+    </p:spTree>
+    <p:extLst>
+      <p:ext uri="{BB962C8B-B14F-4D97-AF65-F5344CB8AC3E}">
+        <p14:creationId xmlns:p14="http://schemas.microsoft.com/office/powerpoint/2010/main" val="1100000100"/>
+      </p:ext>
+    </p:extLst>
+  </p:cSld>
+  <p:clrMapOvr>
+    <a:masterClrMapping/>
+  </p:clrMapOvr>
+</p:sld>
+</file>
+
+<file path=ppt/slides/slide101.xml><?xml version="1.0" encoding="utf-8"?>
+<p:sld xmlns:a="http://schemas.openxmlformats.org/drawingml/2006/main" xmlns:r="http://schemas.openxmlformats.org/officeDocument/2006/relationships" xmlns:p="http://schemas.openxmlformats.org/presentationml/2006/main">
+  <p:cSld>
+    <p:spTree>
+      <p:nvGrpSpPr>
+        <p:cNvPr id="1" name=""/>
+        <p:cNvGrpSpPr/>
+        <p:nvPr/>
+      </p:nvGrpSpPr>
+      <p:grpSpPr>
+        <a:xfrm>
+          <a:off x="0" y="0"/>
+          <a:ext cx="0" cy="0"/>
+          <a:chOff x="0" y="0"/>
+          <a:chExt cx="0" cy="0"/>
+        </a:xfrm>
+      </p:grpSpPr>
+      <p:sp>
+        <p:nvSpPr>
+          <p:cNvPr id="2" name="Slide Number Placeholder"/>
+          <p:cNvSpPr>
+            <a:spLocks noGrp="1"/>
+          </p:cNvSpPr>
+          <p:nvPr>
+            <p:ph type="sldNum" sz="quarter" idx="12"/>
+          </p:nvPr>
+        </p:nvSpPr>
+        <p:spPr/>
+        <p:txBody>
+          <a:bodyPr/>
+          <a:lstStyle/>
+          <a:p>
+            <a:fld id="{5AF2E7C1-CA82-F241-8934-AACDE30393F4}" type="slidenum">
+              <a:rPr lang="en-GB" smtClean="0"/>
+              <a:pPr/>
+              <a:t>2</a:t>
+            </a:fld>
+            <a:endParaRPr lang="en-GB" dirty="0"/>
+          </a:p>
+        </p:txBody>
+      </p:sp>
+      <p:sp>
+        <p:nvSpPr>
+          <p:cNvPr id="3" name="Title Placeholder"/>
+          <p:cNvSpPr>
+            <a:spLocks noGrp="1"/>
+          </p:cNvSpPr>
+          <p:nvPr>
+            <p:ph type="body" sz="quarter" idx="13"/>
+          </p:nvPr>
+        </p:nvSpPr>
+        <p:spPr/>
+        <p:txBody>
+          <a:bodyPr/>
+          <a:lstStyle/>
+          <a:p>
+            <a:pPr lvl="0"/>
+            <a:r>
+              <a:rPr lang="en-GB" dirty="0"/>
+              <a:t>Recap of Previous Proposals</a:t>
+            </a:r>
+          </a:p>
+        </p:txBody>
+      </p:sp>
+      <p:sp>
+        <p:nvSpPr>
+          <p:cNvPr id="4" name="Subtitle Placeholder"/>
+          <p:cNvSpPr>
+            <a:spLocks noGrp="1"/>
+          </p:cNvSpPr>
+          <p:nvPr>
+            <p:ph type="body" sz="quarter" idx="14"/>
+          </p:nvPr>
+        </p:nvSpPr>
+        <p:spPr/>
+        <p:txBody>
+          <a:bodyPr/>
+          <a:lstStyle/>
+          <a:p>
+            <a:pPr lvl="0"/>
+            <a:r>
+              <a:rPr lang="en-GB" dirty="0"/>
+              <a:t>Starting point before the current evaluation</a:t>
+            </a:r>
+          </a:p>
+        </p:txBody>
+      </p:sp>
+      <p:sp>
+        <p:nvSpPr>
+          <p:cNvPr id="5" name="Footer Placeholder"/>
+          <p:cNvSpPr>
+            <a:spLocks noGrp="1"/>
+          </p:cNvSpPr>
+          <p:nvPr>
+            <p:ph type="ftr" sz="quarter" idx="15"/>
+          </p:nvPr>
+        </p:nvSpPr>
+        <p:spPr/>
+        <p:txBody>
+          <a:bodyPr/>
+          <a:lstStyle/>
+          <a:p>
+            <a:r>
+              <a:rPr lang="en-GB"/>
+              <a:t>PPT Template 2.0</a:t>
+            </a:r>
+            <a:endParaRPr lang="en-GB" dirty="0"/>
+          </a:p>
+        </p:txBody>
+      </p:sp>
+      <p:sp>
+        <p:nvSpPr>
+          <p:cNvPr id="6" name="Body Left Placeholder"/>
+          <p:cNvSpPr>
+            <a:spLocks noGrp="1"/>
+          </p:cNvSpPr>
+          <p:nvPr>
+            <p:ph type="body" sz="quarter" idx="16"/>
+          </p:nvPr>
+        </p:nvSpPr>
+        <p:spPr/>
+        <p:txBody>
+          <a:bodyPr>
+            <a:normAutofit/>
+          </a:bodyPr>
+          <a:lstStyle/>
+          <a:p>
+            <a:pPr lvl="4"/>
+            <a:r>
+              <a:rPr lang="en-GB" dirty="0"/>
+              <a:t>The previous evaluation round for the DAKVI squad covered AirPy, NiFi and Infa; AirPy was recommended for the squad</a:t>
+            </a:r>
+          </a:p>
+          <a:p>
+            <a:pPr lvl="4"/>
+            <a:r>
+              <a:rPr lang="en-GB" dirty="0"/>
+              <a:t>The B2 — Template Library concept was subsequently approved at ODP SRF</a:t>
+            </a:r>
+          </a:p>
+          <a:p>
+            <a:pPr lvl="4"/>
+            <a:r>
+              <a:rPr lang="en-GB" dirty="0"/>
+              <a:t>Based on a proposal from the vendor (BigHub), the Meltano alternative was added to the evaluation, followed by MiNiFi</a:t>
+            </a:r>
+          </a:p>
+          <a:p>
+            <a:pPr lvl="4"/>
+            <a:r>
+              <a:rPr lang="en-GB" dirty="0"/>
+              <a:t>Both alternatives were verified through a smaller-scale Proof of Concept</a:t>
+            </a:r>
+          </a:p>
+        </p:txBody>
+      </p:sp>
+    </p:spTree>
+    <p:extLst>
+      <p:ext uri="{BB962C8B-B14F-4D97-AF65-F5344CB8AC3E}">
+        <p14:creationId xmlns:p14="http://schemas.microsoft.com/office/powerpoint/2010/main" val="1100000101"/>
+      </p:ext>
+    </p:extLst>
+  </p:cSld>
+  <p:clrMapOvr>
+    <a:masterClrMapping/>
+  </p:clrMapOvr>
+</p:sld>
+</file>
+
+<file path=ppt/slides/slide102.xml><?xml version="1.0" encoding="utf-8"?>
+<p:sld xmlns:a="http://schemas.openxmlformats.org/drawingml/2006/main" xmlns:r="http://schemas.openxmlformats.org/officeDocument/2006/relationships" xmlns:p="http://schemas.openxmlformats.org/presentationml/2006/main">
+  <p:cSld>
+    <p:spTree>
+      <p:nvGrpSpPr>
+        <p:cNvPr id="1" name=""/>
+        <p:cNvGrpSpPr/>
+        <p:nvPr/>
+      </p:nvGrpSpPr>
+      <p:grpSpPr>
+        <a:xfrm>
+          <a:off x="0" y="0"/>
+          <a:ext cx="0" cy="0"/>
+          <a:chOff x="0" y="0"/>
+          <a:chExt cx="0" cy="0"/>
+        </a:xfrm>
+      </p:grpSpPr>
+      <p:sp>
+        <p:nvSpPr>
+          <p:cNvPr id="2" name="Slide Number Placeholder"/>
+          <p:cNvSpPr>
+            <a:spLocks noGrp="1"/>
+          </p:cNvSpPr>
+          <p:nvPr>
+            <p:ph type="sldNum" sz="quarter" idx="12"/>
+          </p:nvPr>
+        </p:nvSpPr>
+        <p:spPr/>
+        <p:txBody>
+          <a:bodyPr/>
+          <a:lstStyle/>
+          <a:p>
+            <a:fld id="{5AF2E7C1-CA82-F241-8934-AACDE30393F4}" type="slidenum">
+              <a:rPr lang="en-GB" smtClean="0"/>
+              <a:pPr/>
+              <a:t>3</a:t>
+            </a:fld>
+            <a:endParaRPr lang="en-GB" dirty="0"/>
+          </a:p>
+        </p:txBody>
+      </p:sp>
+      <p:sp>
+        <p:nvSpPr>
+          <p:cNvPr id="3" name="Title Placeholder"/>
+          <p:cNvSpPr>
+            <a:spLocks noGrp="1"/>
+          </p:cNvSpPr>
+          <p:nvPr>
+            <p:ph type="body" sz="quarter" idx="13"/>
+          </p:nvPr>
+        </p:nvSpPr>
+        <p:spPr/>
+        <p:txBody>
+          <a:bodyPr/>
+          <a:lstStyle/>
+          <a:p>
+            <a:pPr lvl="0"/>
+            <a:r>
+              <a:rPr lang="en-GB" dirty="0"/>
+              <a:t>Rejection of the Meltano Alternative</a:t>
+            </a:r>
+          </a:p>
+        </p:txBody>
+      </p:sp>
+      <p:sp>
+        <p:nvSpPr>
+          <p:cNvPr id="4" name="Subtitle Placeholder"/>
+          <p:cNvSpPr>
+            <a:spLocks noGrp="1"/>
+          </p:cNvSpPr>
+          <p:nvPr>
+            <p:ph type="body" sz="quarter" idx="14"/>
+          </p:nvPr>
+        </p:nvSpPr>
+        <p:spPr/>
+        <p:txBody>
+          <a:bodyPr/>
+          <a:lstStyle/>
+          <a:p>
+            <a:pPr lvl="0"/>
+            <a:r>
+              <a:rPr lang="en-GB" dirty="0"/>
+              <a:t>Proof of Concept results</a:t>
+            </a:r>
+          </a:p>
+        </p:txBody>
+      </p:sp>
+      <p:sp>
+        <p:nvSpPr>
+          <p:cNvPr id="5" name="Footer Placeholder"/>
+          <p:cNvSpPr>
+            <a:spLocks noGrp="1"/>
+          </p:cNvSpPr>
+          <p:nvPr>
+            <p:ph type="ftr" sz="quarter" idx="15"/>
+          </p:nvPr>
+        </p:nvSpPr>
+        <p:spPr/>
+        <p:txBody>
+          <a:bodyPr/>
+          <a:lstStyle/>
+          <a:p>
+            <a:r>
+              <a:rPr lang="en-GB"/>
+              <a:t>PPT Template 2.0</a:t>
+            </a:r>
+            <a:endParaRPr lang="en-GB" dirty="0"/>
+          </a:p>
+        </p:txBody>
+      </p:sp>
+      <p:sp>
+        <p:nvSpPr>
+          <p:cNvPr id="6" name="Body Left Placeholder"/>
+          <p:cNvSpPr>
+            <a:spLocks noGrp="1"/>
+          </p:cNvSpPr>
+          <p:nvPr>
+            <p:ph type="body" sz="quarter" idx="16"/>
+          </p:nvPr>
+        </p:nvSpPr>
+        <p:spPr/>
+        <p:txBody>
+          <a:bodyPr>
+            <a:normAutofit fontScale="85000" lnSpcReduction="10000"/>
+          </a:bodyPr>
+          <a:lstStyle/>
+          <a:p>
+            <a:pPr lvl="4"/>
+            <a:r>
+              <a:rPr lang="en-GB" dirty="0"/>
+              <a:t>Exporting 80 million records took approximately 4 hours with Meltano</a:t>
+            </a:r>
+          </a:p>
+          <a:p>
+            <a:pPr lvl="4"/>
+            <a:r>
+              <a:rPr lang="en-GB" dirty="0"/>
+              <a:t>The other evaluated alternatives achieved significantly shorter times: AirPy 5 minutes, Informatica 8 minutes, Apache NiFi 15 minutes</a:t>
+            </a:r>
+          </a:p>
+          <a:p>
+            <a:pPr lvl="4"/>
+            <a:r>
+              <a:rPr lang="en-GB" dirty="0"/>
+              <a:t>Meltano’s performance is an order of magnitude lower than the other evaluated solutions</a:t>
+            </a:r>
+          </a:p>
+          <a:p>
+            <a:pPr lvl="4"/>
+            <a:r>
+              <a:rPr lang="en-GB" dirty="0"/>
+              <a:t>Part of the slowdown stems from the Singer specification itself, on which Meltano is built — for larger volumes it uses the BATCH message mechanism, where data is first written to intermediate storage and only then loaded into the target</a:t>
+            </a:r>
+          </a:p>
+          <a:p>
+            <a:pPr lvl="4"/>
+            <a:r>
+              <a:rPr lang="en-GB" dirty="0"/>
+              <a:t>This could likely be optimized, but we decided not to pursue it further — it would require flow-specific optimization with an uncertain outcome</a:t>
+            </a:r>
+          </a:p>
+          <a:p>
+            <a:pPr lvl="4"/>
+            <a:r>
+              <a:rPr lang="en-GB" dirty="0"/>
+              <a:t>Meltano can also only load data into Teradata — a connector for exporting data from Teradata does not exist for this tool</a:t>
+            </a:r>
+          </a:p>
+          <a:p>
+            <a:pPr lvl="4"/>
+            <a:r>
+              <a:rPr lang="en-GB" dirty="0"/>
+              <a:t>Based on these results, the Meltano alternative was rejected from further evaluation</a:t>
+            </a:r>
+          </a:p>
+        </p:txBody>
+      </p:sp>
+    </p:spTree>
+    <p:extLst>
+      <p:ext uri="{BB962C8B-B14F-4D97-AF65-F5344CB8AC3E}">
+        <p14:creationId xmlns:p14="http://schemas.microsoft.com/office/powerpoint/2010/main" val="1100000102"/>
+      </p:ext>
+    </p:extLst>
+  </p:cSld>
+  <p:clrMapOvr>
+    <a:masterClrMapping/>
+  </p:clrMapOvr>
+</p:sld>
+</file>
+
+<file path=ppt/slides/slide103.xml><?xml version="1.0" encoding="utf-8"?>
+<p:sld xmlns:a="http://schemas.openxmlformats.org/drawingml/2006/main" xmlns:r="http://schemas.openxmlformats.org/officeDocument/2006/relationships" xmlns:p="http://schemas.openxmlformats.org/presentationml/2006/main">
+  <p:cSld>
+    <p:spTree>
+      <p:nvGrpSpPr>
+        <p:cNvPr id="1" name=""/>
+        <p:cNvGrpSpPr/>
+        <p:nvPr/>
+      </p:nvGrpSpPr>
+      <p:grpSpPr>
+        <a:xfrm>
+          <a:off x="0" y="0"/>
+          <a:ext cx="0" cy="0"/>
+          <a:chOff x="0" y="0"/>
+          <a:chExt cx="0" cy="0"/>
+        </a:xfrm>
+      </p:grpSpPr>
+      <p:sp>
+        <p:nvSpPr>
+          <p:cNvPr id="2" name="Slide Number Placeholder"/>
+          <p:cNvSpPr>
+            <a:spLocks noGrp="1"/>
+          </p:cNvSpPr>
+          <p:nvPr>
+            <p:ph type="sldNum" sz="quarter" idx="12"/>
+          </p:nvPr>
+        </p:nvSpPr>
+        <p:spPr/>
+        <p:txBody>
+          <a:bodyPr/>
+          <a:lstStyle/>
+          <a:p>
+            <a:fld id="{5AF2E7C1-CA82-F241-8934-AACDE30393F4}" type="slidenum">
+              <a:rPr lang="en-GB" smtClean="0"/>
+              <a:pPr/>
+              <a:t>4</a:t>
+            </a:fld>
+            <a:endParaRPr lang="en-GB" dirty="0"/>
+          </a:p>
+        </p:txBody>
+      </p:sp>
+      <p:sp>
+        <p:nvSpPr>
+          <p:cNvPr id="3" name="Title Placeholder"/>
+          <p:cNvSpPr>
+            <a:spLocks noGrp="1"/>
+          </p:cNvSpPr>
+          <p:nvPr>
+            <p:ph type="body" sz="quarter" idx="13"/>
+          </p:nvPr>
+        </p:nvSpPr>
+        <p:spPr/>
+        <p:txBody>
+          <a:bodyPr/>
+          <a:lstStyle/>
+          <a:p>
+            <a:pPr lvl="0"/>
+            <a:r>
+              <a:rPr lang="en-GB" dirty="0"/>
+              <a:t>Architecture Independent of the Tool Choice</a:t>
+            </a:r>
+          </a:p>
+        </p:txBody>
+      </p:sp>
+      <p:sp>
+        <p:nvSpPr>
+          <p:cNvPr id="4" name="Subtitle Placeholder"/>
+          <p:cNvSpPr>
+            <a:spLocks noGrp="1"/>
+          </p:cNvSpPr>
+          <p:nvPr>
+            <p:ph type="body" sz="quarter" idx="14"/>
+          </p:nvPr>
+        </p:nvSpPr>
+        <p:spPr/>
+        <p:txBody>
+          <a:bodyPr/>
+          <a:lstStyle/>
+          <a:p>
+            <a:pPr lvl="0"/>
+            <a:r>
+              <a:rPr lang="en-GB" dirty="0"/>
+              <a:t>Versioned Template Library principle (variant B2)</a:t>
+            </a:r>
+          </a:p>
+        </p:txBody>
+      </p:sp>
+      <p:sp>
+        <p:nvSpPr>
+          <p:cNvPr id="5" name="Footer Placeholder"/>
+          <p:cNvSpPr>
+            <a:spLocks noGrp="1"/>
+          </p:cNvSpPr>
+          <p:nvPr>
+            <p:ph type="ftr" sz="quarter" idx="15"/>
+          </p:nvPr>
+        </p:nvSpPr>
+        <p:spPr/>
+        <p:txBody>
+          <a:bodyPr/>
+          <a:lstStyle/>
+          <a:p>
+            <a:r>
+              <a:rPr lang="en-GB"/>
+              <a:t>PPT Template 2.0</a:t>
+            </a:r>
+            <a:endParaRPr lang="en-GB" dirty="0"/>
+          </a:p>
+        </p:txBody>
+      </p:sp>
+      <p:sp>
+        <p:nvSpPr>
+          <p:cNvPr id="6" name="Body Left Placeholder"/>
+          <p:cNvSpPr>
+            <a:spLocks noGrp="1"/>
+          </p:cNvSpPr>
+          <p:nvPr>
+            <p:ph type="body" sz="quarter" idx="16"/>
+          </p:nvPr>
+        </p:nvSpPr>
+        <p:spPr/>
+        <p:txBody>
+          <a:bodyPr>
+            <a:normAutofit/>
+          </a:bodyPr>
+          <a:lstStyle/>
+          <a:p>
+            <a:pPr lvl="4"/>
+            <a:r>
+              <a:rPr lang="en-GB" dirty="0"/>
+              <a:t>The chosen architectural model remains valid regardless of the outcome of the tool evaluation</a:t>
+            </a:r>
+          </a:p>
+          <a:p>
+            <a:pPr lvl="4"/>
+            <a:r>
+              <a:rPr lang="en-GB" dirty="0"/>
+              <a:t>The business squad deploys a versioned copy of the template and its own configuration in its own Git repository</a:t>
+            </a:r>
+          </a:p>
+          <a:p>
+            <a:pPr lvl="4"/>
+            <a:r>
+              <a:rPr lang="en-GB" dirty="0"/>
+              <a:t>The business squad is responsible for deployment, operation, and upgrade decisions</a:t>
+            </a:r>
+          </a:p>
+          <a:p>
+            <a:pPr lvl="4"/>
+            <a:r>
+              <a:rPr lang="en-GB" dirty="0"/>
+              <a:t>The configuration components remain unchanged: Object Schema, Export Configuration, Run Conditions</a:t>
+            </a:r>
+          </a:p>
+          <a:p>
+            <a:pPr lvl="4"/>
+            <a:r>
+              <a:rPr lang="en-GB" dirty="0"/>
+              <a:t>The choice of the specific tool (AirPy, MiNiFi) affects only the implementation, not how business squads use this architecture</a:t>
+            </a:r>
+          </a:p>
+        </p:txBody>
+      </p:sp>
+    </p:spTree>
+    <p:extLst>
+      <p:ext uri="{BB962C8B-B14F-4D97-AF65-F5344CB8AC3E}">
+        <p14:creationId xmlns:p14="http://schemas.microsoft.com/office/powerpoint/2010/main" val="1100000103"/>
+      </p:ext>
+    </p:extLst>
+  </p:cSld>
+  <p:clrMapOvr>
+    <a:masterClrMapping/>
+  </p:clrMapOvr>
+</p:sld>
+</file>
+
+<file path=ppt/slides/slide104.xml><?xml version="1.0" encoding="utf-8"?>
+<p:sld xmlns:a="http://schemas.openxmlformats.org/drawingml/2006/main" xmlns:r="http://schemas.openxmlformats.org/officeDocument/2006/relationships" xmlns:p="http://schemas.openxmlformats.org/presentationml/2006/main">
+  <p:cSld>
+    <p:spTree>
+      <p:nvGrpSpPr>
+        <p:cNvPr id="1" name=""/>
+        <p:cNvGrpSpPr/>
+        <p:nvPr/>
+      </p:nvGrpSpPr>
+      <p:grpSpPr>
+        <a:xfrm>
+          <a:off x="0" y="0"/>
+          <a:ext cx="0" cy="0"/>
+          <a:chOff x="0" y="0"/>
+          <a:chExt cx="0" cy="0"/>
+        </a:xfrm>
+      </p:grpSpPr>
+      <p:sp>
+        <p:nvSpPr>
+          <p:cNvPr id="2" name="Slide Number Placeholder"/>
+          <p:cNvSpPr>
+            <a:spLocks noGrp="1"/>
+          </p:cNvSpPr>
+          <p:nvPr>
+            <p:ph type="sldNum" sz="quarter" idx="12"/>
+          </p:nvPr>
+        </p:nvSpPr>
+        <p:spPr/>
+        <p:txBody>
+          <a:bodyPr/>
+          <a:lstStyle/>
+          <a:p>
+            <a:fld id="{5AF2E7C1-CA82-F241-8934-AACDE30393F4}" type="slidenum">
+              <a:rPr lang="en-GB" smtClean="0"/>
+              <a:pPr/>
+              <a:t>7</a:t>
+            </a:fld>
+            <a:endParaRPr lang="en-GB" dirty="0"/>
+          </a:p>
+        </p:txBody>
+      </p:sp>
+      <p:sp>
+        <p:nvSpPr>
+          <p:cNvPr id="3" name="Title Placeholder"/>
+          <p:cNvSpPr>
+            <a:spLocks noGrp="1"/>
+          </p:cNvSpPr>
+          <p:nvPr>
+            <p:ph type="body" sz="quarter" idx="13"/>
+          </p:nvPr>
+        </p:nvSpPr>
+        <p:spPr/>
+        <p:txBody>
+          <a:bodyPr/>
+          <a:lstStyle/>
+          <a:p>
+            <a:pPr lvl="0"/>
+            <a:r>
+              <a:rPr lang="en-GB" dirty="0"/>
+              <a:t>NiFi vs. MiNiFi Comparison</a:t>
+            </a:r>
+          </a:p>
+        </p:txBody>
+      </p:sp>
+      <p:sp>
+        <p:nvSpPr>
+          <p:cNvPr id="4" name="Subtitle Placeholder"/>
+          <p:cNvSpPr>
+            <a:spLocks noGrp="1"/>
+          </p:cNvSpPr>
+          <p:nvPr>
+            <p:ph type="body" sz="quarter" idx="14"/>
+          </p:nvPr>
+        </p:nvSpPr>
+        <p:spPr/>
+        <p:txBody>
+          <a:bodyPr/>
+          <a:lstStyle/>
+          <a:p>
+            <a:pPr lvl="0"/>
+            <a:r>
+              <a:rPr lang="en-GB" dirty="0"/>
+              <a:t>Source of the improved score and its cause</a:t>
+            </a:r>
+          </a:p>
+        </p:txBody>
+      </p:sp>
+      <p:sp>
+        <p:nvSpPr>
+          <p:cNvPr id="5" name="Footer Placeholder"/>
+          <p:cNvSpPr>
+            <a:spLocks noGrp="1"/>
+          </p:cNvSpPr>
+          <p:nvPr>
+            <p:ph type="ftr" sz="quarter" idx="15"/>
+          </p:nvPr>
+        </p:nvSpPr>
+        <p:spPr/>
+        <p:txBody>
+          <a:bodyPr/>
+          <a:lstStyle/>
+          <a:p>
+            <a:r>
+              <a:rPr lang="en-GB"/>
+              <a:t>PPT Template 2.0</a:t>
+            </a:r>
+            <a:endParaRPr lang="en-GB" dirty="0"/>
+          </a:p>
+        </p:txBody>
+      </p:sp>
+      <p:sp>
+        <p:nvSpPr>
+          <p:cNvPr id="6" name="Intro Text"/>
+          <p:cNvSpPr txBox="1"/>
+          <p:nvPr/>
+        </p:nvSpPr>
+        <p:spPr>
+          <a:xfrm>
+            <a:off x="390000" y="1060000"/>
+            <a:ext cx="11410000" cy="640000"/>
+          </a:xfrm>
+          <a:prstGeom prst="rect">
+            <a:avLst/>
+          </a:prstGeom>
+        </p:spPr>
+        <p:txBody>
+          <a:bodyPr wrap="square">
+            <a:normAutofit/>
+          </a:bodyPr>
+          <a:lstStyle/>
+          <a:p>
+            <a:r>
+              <a:rPr lang="en-GB" sz="1400" dirty="0"/>
+              <a:t>Both solutions use the same Apache NiFi processors. The difference lies in the deployment model — MiNiFi runs as a standalone pod started from Airflow, the flow definition is stored as a file in Git, and credential access is handled by the combination of Airflow and Kubernetes. The improved score therefore comes from the deployment model, not from the tool’s core.</a:t>
+            </a:r>
+          </a:p>
+        </p:txBody>
+      </p:sp>
+      <p:graphicFrame>
+        <p:nvGraphicFramePr>
+          <p:cNvPr id="7" name="Comparison Table"/>
+          <p:cNvGraphicFramePr>
+            <a:graphicFrameLocks noGrp="1"/>
+          </p:cNvGraphicFramePr>
+          <p:nvPr/>
+        </p:nvGraphicFramePr>
+        <p:xfrm>
+          <a:off x="390000" y="1780000"/>
+          <a:ext cx="11410000" cy="3400000"/>
+        </p:xfrm>
+        <a:graphic>
+          <a:graphicData uri="http://schemas.openxmlformats.org/drawingml/2006/table">
+            <a:tbl>
+              <a:tblPr firstRow="1" bandRow="1">
+                <a:tableStyleId>{5C22544A-7EE6-4342-B048-85BDC9FD1C3A}</a:tableStyleId>
+              </a:tblPr>
+              <a:tblGrid>
+                <a:gridCol w="5800000"/>
+                <a:gridCol w="1900000"/>
+                <a:gridCol w="1900000"/>
+                <a:gridCol w="1810000"/>
+              </a:tblGrid>
+              <a:tr h="400000">
+                <a:tc>
+                  <a:txBody>
+                    <a:bodyPr/>
+                    <a:lstStyle/>
+                    <a:p>
+                      <a:r>
+                        <a:rPr lang="en-GB" sz="1200" b="1" dirty="0"/>
+                        <a:t>Criterion</a:t>
+                      </a:r>
+                    </a:p>
+                  </a:txBody>
+                  <a:tcPr/>
+                </a:tc>
+                <a:tc>
+                  <a:txBody>
+                    <a:bodyPr/>
+                    <a:lstStyle/>
+                    <a:p>
+                      <a:r>
+                        <a:rPr lang="en-GB" sz="1200" b="1" dirty="0"/>
+                        <a:t>NiFi</a:t>
+                      </a:r>
+                    </a:p>
+                  </a:txBody>
+                  <a:tcPr/>
+                </a:tc>
+                <a:tc>
+                  <a:txBody>
+                    <a:bodyPr/>
+                    <a:lstStyle/>
+                    <a:p>
+                      <a:r>
+                        <a:rPr lang="en-GB" sz="1200" b="1" dirty="0"/>
+                        <a:t>MiNiFi</a:t>
+                      </a:r>
+                    </a:p>
+                  </a:txBody>
+                  <a:tcPr/>
+                </a:tc>
+                <a:tc>
+                  <a:txBody>
+                    <a:bodyPr/>
+                    <a:lstStyle/>
+                    <a:p>
+                      <a:r>
+                        <a:rPr lang="en-GB" sz="1200" b="1" dirty="0"/>
+                        <a:t>Difference</a:t>
+                      </a:r>
+                    </a:p>
+                  </a:txBody>
+                  <a:tcPr/>
+                </a:tc>
+              </a:tr>
+              <a:tr h="330000">
+                <a:tc>
+                  <a:txBody>
+                    <a:bodyPr/>
+                    <a:lstStyle/>
+                    <a:p>
+                      <a:r>
+                        <a:rPr lang="en-GB" sz="1100" dirty="0"/>
+                        <a:t>YAML configuration consistency in CI/CD</a:t>
+                      </a:r>
+                    </a:p>
+                  </a:txBody>
+                  <a:tcPr/>
+                </a:tc>
+                <a:tc>
+                  <a:txBody>
+                    <a:bodyPr/>
+                    <a:lstStyle/>
+                    <a:p>
+                      <a:r>
+                        <a:rPr lang="en-GB" sz="1100" dirty="0"/>
+                        <a:t>8</a:t>
+                      </a:r>
+                    </a:p>
+                  </a:txBody>
+                  <a:tcPr/>
+                </a:tc>
+                <a:tc>
+                  <a:txBody>
+                    <a:bodyPr/>
+                    <a:lstStyle/>
+                    <a:p>
+                      <a:r>
+                        <a:rPr lang="en-GB" sz="1100" dirty="0"/>
+                        <a:t>1</a:t>
+                      </a:r>
+                    </a:p>
+                  </a:txBody>
+                  <a:tcPr/>
+                </a:tc>
+                <a:tc>
+                  <a:txBody>
+                    <a:bodyPr/>
+                    <a:lstStyle/>
+                    <a:p>
+                      <a:r>
+                        <a:rPr lang="en-GB" sz="1100" b="1" dirty="0"/>
+                        <a:t>-7</a:t>
+                      </a:r>
+                    </a:p>
+                  </a:txBody>
+                  <a:tcPr/>
+                </a:tc>
+              </a:tr>
+              <a:tr h="330000">
+                <a:tc>
+                  <a:txBody>
+                    <a:bodyPr/>
+                    <a:lstStyle/>
+                    <a:p>
+                      <a:r>
+                        <a:rPr lang="en-GB" sz="1100" dirty="0"/>
+                        <a:t>Git support in CI/CD</a:t>
+                      </a:r>
+                    </a:p>
+                  </a:txBody>
+                  <a:tcPr/>
+                </a:tc>
+                <a:tc>
+                  <a:txBody>
+                    <a:bodyPr/>
+                    <a:lstStyle/>
+                    <a:p>
+                      <a:r>
+                        <a:rPr lang="en-GB" sz="1100" dirty="0"/>
+                        <a:t>6</a:t>
+                      </a:r>
+                    </a:p>
+                  </a:txBody>
+                  <a:tcPr/>
+                </a:tc>
+                <a:tc>
+                  <a:txBody>
+                    <a:bodyPr/>
+                    <a:lstStyle/>
+                    <a:p>
+                      <a:r>
+                        <a:rPr lang="en-GB" sz="1100" dirty="0"/>
+                        <a:t>1</a:t>
+                      </a:r>
+                    </a:p>
+                  </a:txBody>
+                  <a:tcPr/>
+                </a:tc>
+                <a:tc>
+                  <a:txBody>
+                    <a:bodyPr/>
+                    <a:lstStyle/>
+                    <a:p>
+                      <a:r>
+                        <a:rPr lang="en-GB" sz="1100" b="1" dirty="0"/>
+                        <a:t>-5</a:t>
+                      </a:r>
+                    </a:p>
+                  </a:txBody>
+                  <a:tcPr/>
+                </a:tc>
+              </a:tr>
+              <a:tr h="330000">
+                <a:tc>
+                  <a:txBody>
+                    <a:bodyPr/>
+                    <a:lstStyle/>
+                    <a:p>
+                      <a:r>
+                        <a:rPr lang="en-GB" sz="1100" dirty="0"/>
+                        <a:t>Alignment with target cloud architecture</a:t>
+                      </a:r>
+                    </a:p>
+                  </a:txBody>
+                  <a:tcPr/>
+                </a:tc>
+                <a:tc>
+                  <a:txBody>
+                    <a:bodyPr/>
+                    <a:lstStyle/>
+                    <a:p>
+                      <a:r>
+                        <a:rPr lang="en-GB" sz="1100" dirty="0"/>
+                        <a:t>7</a:t>
+                      </a:r>
+                    </a:p>
+                  </a:txBody>
+                  <a:tcPr/>
+                </a:tc>
+                <a:tc>
+                  <a:txBody>
+                    <a:bodyPr/>
+                    <a:lstStyle/>
+                    <a:p>
+                      <a:r>
+                        <a:rPr lang="en-GB" sz="1100" dirty="0"/>
+                        <a:t>3 (in K8s)</a:t>
+                      </a:r>
+                    </a:p>
+                  </a:txBody>
+                  <a:tcPr/>
+                </a:tc>
+                <a:tc>
+                  <a:txBody>
+                    <a:bodyPr/>
+                    <a:lstStyle/>
+                    <a:p>
+                      <a:r>
+                        <a:rPr lang="en-GB" sz="1100" b="1" dirty="0"/>
+                        <a:t>-4</a:t>
+                      </a:r>
+                    </a:p>
+                  </a:txBody>
+                  <a:tcPr/>
+                </a:tc>
+              </a:tr>
+              <a:tr h="330000">
+                <a:tc>
+                  <a:txBody>
+                    <a:bodyPr/>
+                    <a:lstStyle/>
+                    <a:p>
+                      <a:r>
+                        <a:rPr lang="en-GB" sz="1100" dirty="0"/>
+                        <a:t>Reuse potential in other entities</a:t>
+                      </a:r>
+                    </a:p>
+                  </a:txBody>
+                  <a:tcPr/>
+                </a:tc>
+                <a:tc>
+                  <a:txBody>
+                    <a:bodyPr/>
+                    <a:lstStyle/>
+                    <a:p>
+                      <a:r>
+                        <a:rPr lang="en-GB" sz="1100" dirty="0"/>
+                        <a:t>5 (DI?)</a:t>
+                      </a:r>
+                    </a:p>
+                  </a:txBody>
+                  <a:tcPr/>
+                </a:tc>
+                <a:tc>
+                  <a:txBody>
+                    <a:bodyPr/>
+                    <a:lstStyle/>
+                    <a:p>
+                      <a:r>
+                        <a:rPr lang="en-GB" sz="1100" dirty="0"/>
+                        <a:t>1 (DI)</a:t>
+                      </a:r>
+                    </a:p>
+                  </a:txBody>
+                  <a:tcPr/>
+                </a:tc>
+                <a:tc>
+                  <a:txBody>
+                    <a:bodyPr/>
+                    <a:lstStyle/>
+                    <a:p>
+                      <a:r>
+                        <a:rPr lang="en-GB" sz="1100" b="1" dirty="0"/>
+                        <a:t>-4</a:t>
+                      </a:r>
+                    </a:p>
+                  </a:txBody>
+                  <a:tcPr/>
+                </a:tc>
+              </a:tr>
+              <a:tr h="330000">
+                <a:tc>
+                  <a:txBody>
+                    <a:bodyPr/>
+                    <a:lstStyle/>
+                    <a:p>
+                      <a:r>
+                        <a:rPr lang="en-GB" sz="1100" dirty="0"/>
+                        <a:t>Horizontal scalability (cross-load)</a:t>
+                      </a:r>
+                    </a:p>
+                  </a:txBody>
+                  <a:tcPr/>
+                </a:tc>
+                <a:tc>
+                  <a:txBody>
+                    <a:bodyPr/>
+                    <a:lstStyle/>
+                    <a:p>
+                      <a:r>
+                        <a:rPr lang="en-GB" sz="1100" dirty="0"/>
+                        <a:t>5</a:t>
+                      </a:r>
+                    </a:p>
+                  </a:txBody>
+                  <a:tcPr/>
+                </a:tc>
+                <a:tc>
+                  <a:txBody>
+                    <a:bodyPr/>
+                    <a:lstStyle/>
+                    <a:p>
+                      <a:r>
+                        <a:rPr lang="en-GB" sz="1100" dirty="0"/>
+                        <a:t>1 (with K8s)</a:t>
+                      </a:r>
+                    </a:p>
+                  </a:txBody>
+                  <a:tcPr/>
+                </a:tc>
+                <a:tc>
+                  <a:txBody>
+                    <a:bodyPr/>
+                    <a:lstStyle/>
+                    <a:p>
+                      <a:r>
+                        <a:rPr lang="en-GB" sz="1100" b="1" dirty="0"/>
+                        <a:t>-4</a:t>
+                      </a:r>
+                    </a:p>
+                  </a:txBody>
+                  <a:tcPr/>
+                </a:tc>
+              </a:tr>
+              <a:tr h="330000">
+                <a:tc>
+                  <a:txBody>
+                    <a:bodyPr/>
+                    <a:lstStyle/>
+                    <a:p>
+                      <a:r>
+                        <a:rPr lang="en-GB" sz="1100" dirty="0"/>
+                        <a:t>Ease of environment promotion in CI/CD</a:t>
+                      </a:r>
+                    </a:p>
+                  </a:txBody>
+                  <a:tcPr/>
+                </a:tc>
+                <a:tc>
+                  <a:txBody>
+                    <a:bodyPr/>
+                    <a:lstStyle/>
+                    <a:p>
+                      <a:r>
+                        <a:rPr lang="en-GB" sz="1100" dirty="0"/>
+                        <a:t>5</a:t>
+                      </a:r>
+                    </a:p>
+                  </a:txBody>
+                  <a:tcPr/>
+                </a:tc>
+                <a:tc>
+                  <a:txBody>
+                    <a:bodyPr/>
+                    <a:lstStyle/>
+                    <a:p>
+                      <a:r>
+                        <a:rPr lang="en-GB" sz="1100" dirty="0"/>
+                        <a:t>2</a:t>
+                      </a:r>
+                    </a:p>
+                  </a:txBody>
+                  <a:tcPr/>
+                </a:tc>
+                <a:tc>
+                  <a:txBody>
+                    <a:bodyPr/>
+                    <a:lstStyle/>
+                    <a:p>
+                      <a:r>
+                        <a:rPr lang="en-GB" sz="1100" b="1" dirty="0"/>
+                        <a:t>-3</a:t>
+                      </a:r>
+                    </a:p>
+                  </a:txBody>
+                  <a:tcPr/>
+                </a:tc>
+              </a:tr>
+              <a:tr h="330000">
+                <a:tc>
+                  <a:txBody>
+                    <a:bodyPr/>
+                    <a:lstStyle/>
+                    <a:p>
+                      <a:r>
+                        <a:rPr lang="en-GB" sz="1100" dirty="0"/>
+                        <a:t>Airflow SOGE integration</a:t>
+                      </a:r>
+                    </a:p>
+                  </a:txBody>
+                  <a:tcPr/>
+                </a:tc>
+                <a:tc>
+                  <a:txBody>
+                    <a:bodyPr/>
+                    <a:lstStyle/>
+                    <a:p>
+                      <a:r>
+                        <a:rPr lang="en-GB" sz="1100" dirty="0"/>
+                        <a:t>6 (PJE-REST)</a:t>
+                      </a:r>
+                    </a:p>
+                  </a:txBody>
+                  <a:tcPr/>
+                </a:tc>
+                <a:tc>
+                  <a:txBody>
+                    <a:bodyPr/>
+                    <a:lstStyle/>
+                    <a:p>
+                      <a:r>
+                        <a:rPr lang="en-GB" sz="1100" dirty="0"/>
+                        <a:t>3</a:t>
+                      </a:r>
+                    </a:p>
+                  </a:txBody>
+                  <a:tcPr/>
+                </a:tc>
+                <a:tc>
+                  <a:txBody>
+                    <a:bodyPr/>
+                    <a:lstStyle/>
+                    <a:p>
+                      <a:r>
+                        <a:rPr lang="en-GB" sz="1100" b="1" dirty="0"/>
+                        <a:t>-3</a:t>
+                      </a:r>
+                    </a:p>
+                  </a:txBody>
+                  <a:tcPr/>
+                </a:tc>
+              </a:tr>
+              <a:tr h="330000">
+                <a:tc>
+                  <a:txBody>
+                    <a:bodyPr/>
+                    <a:lstStyle/>
+                    <a:p>
+                      <a:r>
+                        <a:rPr lang="en-GB" sz="1100" dirty="0"/>
+                        <a:t>CyberArk / Vault integration</a:t>
+                      </a:r>
+                    </a:p>
+                  </a:txBody>
+                  <a:tcPr/>
+                </a:tc>
+                <a:tc>
+                  <a:txBody>
+                    <a:bodyPr/>
+                    <a:lstStyle/>
+                    <a:p>
+                      <a:r>
+                        <a:rPr lang="en-GB" sz="1100" dirty="0"/>
+                        <a:t>5</a:t>
+                      </a:r>
+                    </a:p>
+                  </a:txBody>
+                  <a:tcPr/>
+                </a:tc>
+                <a:tc>
+                  <a:txBody>
+                    <a:bodyPr/>
+                    <a:lstStyle/>
+                    <a:p>
+                      <a:r>
+                        <a:rPr lang="en-GB" sz="1100" dirty="0"/>
+                        <a:t>3</a:t>
+                      </a:r>
+                    </a:p>
+                  </a:txBody>
+                  <a:tcPr/>
+                </a:tc>
+                <a:tc>
+                  <a:txBody>
+                    <a:bodyPr/>
+                    <a:lstStyle/>
+                    <a:p>
+                      <a:r>
+                        <a:rPr lang="en-GB" sz="1100" b="1" dirty="0"/>
+                        <a:t>-2</a:t>
+                      </a:r>
+                    </a:p>
+                  </a:txBody>
+                  <a:tcPr/>
+                </a:tc>
+              </a:tr>
+              <a:tr h="330000">
+                <a:tc>
+                  <a:txBody>
+                    <a:bodyPr/>
+                    <a:lstStyle/>
+                    <a:p>
+                      <a:r>
+                        <a:rPr lang="en-GB" sz="1100" dirty="0"/>
+                        <a:t>Squad autonomy</a:t>
+                      </a:r>
+                    </a:p>
+                  </a:txBody>
+                  <a:tcPr/>
+                </a:tc>
+                <a:tc>
+                  <a:txBody>
+                    <a:bodyPr/>
+                    <a:lstStyle/>
+                    <a:p>
+                      <a:r>
+                        <a:rPr lang="en-GB" sz="1100" dirty="0"/>
+                        <a:t>4</a:t>
+                      </a:r>
+                    </a:p>
+                  </a:txBody>
+                  <a:tcPr/>
+                </a:tc>
+                <a:tc>
+                  <a:txBody>
+                    <a:bodyPr/>
+                    <a:lstStyle/>
+                    <a:p>
+                      <a:r>
+                        <a:rPr lang="en-GB" sz="1100" dirty="0"/>
+                        <a:t>2</a:t>
+                      </a:r>
+                    </a:p>
+                  </a:txBody>
+                  <a:tcPr/>
+                </a:tc>
+                <a:tc>
+                  <a:txBody>
+                    <a:bodyPr/>
+                    <a:lstStyle/>
+                    <a:p>
+                      <a:r>
+                        <a:rPr lang="en-GB" sz="1100" b="1" dirty="0"/>
+                        <a:t>-2</a:t>
+                      </a:r>
+                    </a:p>
+                  </a:txBody>
+                  <a:tcPr/>
+                </a:tc>
+              </a:tr>
+            </a:tbl>
+          </a:graphicData>
+        </a:graphic>
+      </p:graphicFrame>
+      <p:sp>
+        <p:nvSpPr>
+          <p:cNvPr id="8" name="Note Text"/>
+          <p:cNvSpPr txBox="1"/>
+          <p:nvPr/>
+        </p:nvSpPr>
+        <p:spPr>
+          <a:xfrm>
+            <a:off x="390000" y="5350000"/>
+            <a:ext cx="11410000" cy="700000"/>
+          </a:xfrm>
+          <a:prstGeom prst="rect">
+            <a:avLst/>
+          </a:prstGeom>
+        </p:spPr>
+        <p:txBody>
+          <a:bodyPr wrap="square">
+            <a:normAutofit/>
+          </a:bodyPr>
+          <a:lstStyle/>
+          <a:p>
+            <a:r>
+              <a:rPr lang="en-GB" sz="1200" i="1" dirty="0"/>
+              <a:t>There is a moderate regression in support for incremental loads (from 0 to 2) — the solution does not use NiFi’s native processor state, but its own watermark management implementation.</a:t>
+            </a:r>
+          </a:p>
+        </p:txBody>
+      </p:sp>
+    </p:spTree>
+    <p:extLst>
+      <p:ext uri="{BB962C8B-B14F-4D97-AF65-F5344CB8AC3E}">
+        <p14:creationId xmlns:p14="http://schemas.microsoft.com/office/powerpoint/2010/main" val="1100000104"/>
+      </p:ext>
+    </p:extLst>
+  </p:cSld>
+  <p:clrMapOvr>
+    <a:masterClrMapping/>
+  </p:clrMapOvr>
+</p:sld>
+</file>
+
+<file path=ppt/slides/slide105.xml><?xml version="1.0" encoding="utf-8"?>
+<p:sld xmlns:a="http://schemas.openxmlformats.org/drawingml/2006/main" xmlns:r="http://schemas.openxmlformats.org/officeDocument/2006/relationships" xmlns:p="http://schemas.openxmlformats.org/presentationml/2006/main">
+  <p:cSld>
+    <p:spTree>
+      <p:nvGrpSpPr>
+        <p:cNvPr id="1" name=""/>
+        <p:cNvGrpSpPr/>
+        <p:nvPr/>
+      </p:nvGrpSpPr>
+      <p:grpSpPr>
+        <a:xfrm>
+          <a:off x="0" y="0"/>
+          <a:ext cx="0" cy="0"/>
+          <a:chOff x="0" y="0"/>
+          <a:chExt cx="0" cy="0"/>
+        </a:xfrm>
+      </p:grpSpPr>
+      <p:sp>
+        <p:nvSpPr>
+          <p:cNvPr id="2" name="Slide Number Placeholder"/>
+          <p:cNvSpPr>
+            <a:spLocks noGrp="1"/>
+          </p:cNvSpPr>
+          <p:nvPr>
+            <p:ph type="sldNum" sz="quarter" idx="12"/>
+          </p:nvPr>
+        </p:nvSpPr>
+        <p:spPr/>
+        <p:txBody>
+          <a:bodyPr/>
+          <a:lstStyle/>
+          <a:p>
+            <a:fld id="{5AF2E7C1-CA82-F241-8934-AACDE30393F4}" type="slidenum">
+              <a:rPr lang="en-GB" smtClean="0"/>
+              <a:pPr/>
+              <a:t>8</a:t>
+            </a:fld>
+            <a:endParaRPr lang="en-GB" dirty="0"/>
+          </a:p>
+        </p:txBody>
+      </p:sp>
+      <p:sp>
+        <p:nvSpPr>
+          <p:cNvPr id="3" name="Title Placeholder"/>
+          <p:cNvSpPr>
+            <a:spLocks noGrp="1"/>
+          </p:cNvSpPr>
+          <p:nvPr>
+            <p:ph type="body" sz="quarter" idx="13"/>
+          </p:nvPr>
+        </p:nvSpPr>
+        <p:spPr/>
+        <p:txBody>
+          <a:bodyPr/>
+          <a:lstStyle/>
+          <a:p>
+            <a:pPr lvl="0"/>
+            <a:r>
+              <a:rPr lang="en-GB" dirty="0"/>
+              <a:t>Rationale — Why AirPy Was Not Selected</a:t>
+            </a:r>
+          </a:p>
+        </p:txBody>
+      </p:sp>
+      <p:sp>
+        <p:nvSpPr>
+          <p:cNvPr id="4" name="Subtitle Placeholder"/>
+          <p:cNvSpPr>
+            <a:spLocks noGrp="1"/>
+          </p:cNvSpPr>
+          <p:nvPr>
+            <p:ph type="body" sz="quarter" idx="14"/>
+          </p:nvPr>
+        </p:nvSpPr>
+        <p:spPr/>
+        <p:txBody>
+          <a:bodyPr/>
+          <a:lstStyle/>
+          <a:p>
+            <a:pPr lvl="0"/>
+            <a:r>
+              <a:rPr lang="en-GB" dirty="0"/>
+              <a:t>A strong score does not necessarily mean the best choice</a:t>
+            </a:r>
+          </a:p>
+        </p:txBody>
+      </p:sp>
+      <p:sp>
+        <p:nvSpPr>
+          <p:cNvPr id="5" name="Footer Placeholder"/>
+          <p:cNvSpPr>
+            <a:spLocks noGrp="1"/>
+          </p:cNvSpPr>
+          <p:nvPr>
+            <p:ph type="ftr" sz="quarter" idx="15"/>
+          </p:nvPr>
+        </p:nvSpPr>
+        <p:spPr/>
+        <p:txBody>
+          <a:bodyPr/>
+          <a:lstStyle/>
+          <a:p>
+            <a:r>
+              <a:rPr lang="en-GB"/>
+              <a:t>PPT Template 2.0</a:t>
+            </a:r>
+            <a:endParaRPr lang="en-GB" dirty="0"/>
+          </a:p>
+        </p:txBody>
+      </p:sp>
+      <p:sp>
+        <p:nvSpPr>
+          <p:cNvPr id="6" name="Body Left Placeholder"/>
+          <p:cNvSpPr>
+            <a:spLocks noGrp="1"/>
+          </p:cNvSpPr>
+          <p:nvPr>
+            <p:ph type="body" sz="quarter" idx="16"/>
+          </p:nvPr>
+        </p:nvSpPr>
+        <p:spPr/>
+        <p:txBody>
+          <a:bodyPr>
+            <a:normAutofit/>
+          </a:bodyPr>
+          <a:lstStyle/>
+          <a:p>
+            <a:pPr lvl="4"/>
+            <a:r>
+              <a:rPr lang="en-GB" dirty="0"/>
+              <a:t>AirPy achieves the best results in several categories — performance, operational parameters, availability of internal expertise, compliance with Greenbook requirements</a:t>
+            </a:r>
+          </a:p>
+          <a:p>
+            <a:pPr lvl="4"/>
+            <a:r>
+              <a:rPr lang="en-GB" dirty="0"/>
+              <a:t>However, it requires developing and maintaining a custom framework within Airflow (watermark management, schema validation, Parquet generation)</a:t>
+            </a:r>
+          </a:p>
+          <a:p>
+            <a:pPr lvl="4"/>
+            <a:r>
+              <a:rPr lang="en-GB" dirty="0"/>
+              <a:t>Supporting Kafka and Elasticsearch would require adding a second tool (NiFi), meaning operating two technology stacks and two CI/CD processes</a:t>
+            </a:r>
+          </a:p>
+          <a:p>
+            <a:pPr lvl="4"/>
+            <a:r>
+              <a:rPr lang="en-GB" dirty="0"/>
+              <a:t>MiNiFi, by contrast, covers all source systems with a single tool, using ready-made components instead of custom development</a:t>
+            </a:r>
+          </a:p>
+        </p:txBody>
+      </p:sp>
+    </p:spTree>
+    <p:extLst>
+      <p:ext uri="{BB962C8B-B14F-4D97-AF65-F5344CB8AC3E}">
+        <p14:creationId xmlns:p14="http://schemas.microsoft.com/office/powerpoint/2010/main" val="1100000105"/>
+      </p:ext>
+    </p:extLst>
+  </p:cSld>
+  <p:clrMapOvr>
+    <a:masterClrMapping/>
+  </p:clrMapOvr>
+</p:sld>
+</file>
+
+<file path=ppt/slides/slide106.xml><?xml version="1.0" encoding="utf-8"?>
+<p:sld xmlns:a="http://schemas.openxmlformats.org/drawingml/2006/main" xmlns:r="http://schemas.openxmlformats.org/officeDocument/2006/relationships" xmlns:p="http://schemas.openxmlformats.org/presentationml/2006/main">
+  <p:cSld>
+    <p:spTree>
+      <p:nvGrpSpPr>
+        <p:cNvPr id="1" name=""/>
+        <p:cNvGrpSpPr/>
+        <p:nvPr/>
+      </p:nvGrpSpPr>
+      <p:grpSpPr>
+        <a:xfrm>
+          <a:off x="0" y="0"/>
+          <a:ext cx="0" cy="0"/>
+          <a:chOff x="0" y="0"/>
+          <a:chExt cx="0" cy="0"/>
+        </a:xfrm>
+      </p:grpSpPr>
+      <p:sp>
+        <p:nvSpPr>
+          <p:cNvPr id="2" name="Slide Number Placeholder"/>
+          <p:cNvSpPr>
+            <a:spLocks noGrp="1"/>
+          </p:cNvSpPr>
+          <p:nvPr>
+            <p:ph type="sldNum" sz="quarter" idx="12"/>
+          </p:nvPr>
+        </p:nvSpPr>
+        <p:spPr/>
+        <p:txBody>
+          <a:bodyPr/>
+          <a:lstStyle/>
+          <a:p>
+            <a:fld id="{5AF2E7C1-CA82-F241-8934-AACDE30393F4}" type="slidenum">
+              <a:rPr lang="en-GB" smtClean="0"/>
+              <a:pPr/>
+              <a:t>9</a:t>
+            </a:fld>
+            <a:endParaRPr lang="en-GB" dirty="0"/>
+          </a:p>
+        </p:txBody>
+      </p:sp>
+      <p:sp>
+        <p:nvSpPr>
+          <p:cNvPr id="3" name="Title Placeholder"/>
+          <p:cNvSpPr>
+            <a:spLocks noGrp="1"/>
+          </p:cNvSpPr>
+          <p:nvPr>
+            <p:ph type="body" sz="quarter" idx="13"/>
+          </p:nvPr>
+        </p:nvSpPr>
+        <p:spPr/>
+        <p:txBody>
+          <a:bodyPr/>
+          <a:lstStyle/>
+          <a:p>
+            <a:pPr lvl="0"/>
+            <a:r>
+              <a:rPr lang="en-GB" dirty="0"/>
+              <a:t>Proof of Concept Results</a:t>
+            </a:r>
+          </a:p>
+        </p:txBody>
+      </p:sp>
+      <p:sp>
+        <p:nvSpPr>
+          <p:cNvPr id="4" name="Subtitle Placeholder"/>
+          <p:cNvSpPr>
+            <a:spLocks noGrp="1"/>
+          </p:cNvSpPr>
+          <p:nvPr>
+            <p:ph type="body" sz="quarter" idx="14"/>
+          </p:nvPr>
+        </p:nvSpPr>
+        <p:spPr/>
+        <p:txBody>
+          <a:bodyPr/>
+          <a:lstStyle/>
+          <a:p>
+            <a:pPr lvl="0"/>
+            <a:r>
+              <a:rPr lang="en-GB" dirty="0"/>
+              <a:t>Comparison of the remaining alternatives</a:t>
+            </a:r>
+          </a:p>
+        </p:txBody>
+      </p:sp>
+      <p:sp>
+        <p:nvSpPr>
+          <p:cNvPr id="5" name="Footer Placeholder"/>
+          <p:cNvSpPr>
+            <a:spLocks noGrp="1"/>
+          </p:cNvSpPr>
+          <p:nvPr>
+            <p:ph type="ftr" sz="quarter" idx="15"/>
+          </p:nvPr>
+        </p:nvSpPr>
+        <p:spPr/>
+        <p:txBody>
+          <a:bodyPr/>
+          <a:lstStyle/>
+          <a:p>
+            <a:r>
+              <a:rPr lang="en-GB"/>
+              <a:t>PPT Template 2.0</a:t>
+            </a:r>
+            <a:endParaRPr lang="en-GB" dirty="0"/>
+          </a:p>
+        </p:txBody>
+      </p:sp>
+      <p:graphicFrame>
+        <p:nvGraphicFramePr>
+          <p:cNvPr id="6" name="PoC Table"/>
+          <p:cNvGraphicFramePr>
+            <a:graphicFrameLocks noGrp="1"/>
+          </p:cNvGraphicFramePr>
+          <p:nvPr/>
+        </p:nvGraphicFramePr>
+        <p:xfrm>
+          <a:off x="390000" y="1900000"/>
+          <a:ext cx="11410000" cy="1350000"/>
+        </p:xfrm>
+        <a:graphic>
+          <a:graphicData uri="http://schemas.openxmlformats.org/drawingml/2006/table">
+            <a:tbl>
+              <a:tblPr firstRow="1" bandRow="1">
+                <a:tableStyleId>{5C22544A-7EE6-4342-B048-85BDC9FD1C3A}</a:tableStyleId>
+              </a:tblPr>
+              <a:tblGrid>
+                <a:gridCol w="3400000"/>
+                <a:gridCol w="2002500"/>
+                <a:gridCol w="2002500"/>
+                <a:gridCol w="2002500"/>
+                <a:gridCol w="2002500"/>
+              </a:tblGrid>
+              <a:tr h="450000">
+                <a:tc>
+                  <a:txBody>
+                    <a:bodyPr/>
+                    <a:lstStyle/>
+                    <a:p>
+                      <a:endParaRPr lang="en-GB" sz="1300" b="1" dirty="0"/>
+                    </a:p>
+                  </a:txBody>
+                  <a:tcPr/>
+                </a:tc>
+                <a:tc>
+                  <a:txBody>
+                    <a:bodyPr/>
+                    <a:lstStyle/>
+                    <a:p>
+                      <a:r>
+                        <a:rPr lang="en-GB" sz="1300" b="1" dirty="0"/>
+                        <a:t>AirPy</a:t>
+                      </a:r>
+                    </a:p>
+                  </a:txBody>
+                  <a:tcPr/>
+                </a:tc>
+                <a:tc>
+                  <a:txBody>
+                    <a:bodyPr/>
+                    <a:lstStyle/>
+                    <a:p>
+                      <a:r>
+                        <a:rPr lang="en-GB" sz="1300" b="1" dirty="0"/>
+                        <a:t>Informatica</a:t>
+                      </a:r>
+                    </a:p>
+                  </a:txBody>
+                  <a:tcPr/>
+                </a:tc>
+                <a:tc>
+                  <a:txBody>
+                    <a:bodyPr/>
+                    <a:lstStyle/>
+                    <a:p>
+                      <a:r>
+                        <a:rPr lang="en-GB" sz="1300" b="1" dirty="0"/>
+                        <a:t>NiFi</a:t>
+                      </a:r>
+                    </a:p>
+                  </a:txBody>
+                  <a:tcPr/>
+                </a:tc>
+                <a:tc>
+                  <a:txBody>
+                    <a:bodyPr/>
+                    <a:lstStyle/>
+                    <a:p>
+                      <a:r>
+                        <a:rPr lang="en-GB" sz="1300" b="1" dirty="0"/>
+                        <a:t>MiNiFi</a:t>
+                      </a:r>
+                    </a:p>
+                  </a:txBody>
+                  <a:tcPr/>
+                </a:tc>
+              </a:tr>
+              <a:tr h="450000">
+                <a:tc>
+                  <a:txBody>
+                    <a:bodyPr/>
+                    <a:lstStyle/>
+                    <a:p>
+                      <a:r>
+                        <a:rPr lang="en-GB" sz="1200" dirty="0"/>
+                        <a:t>Export of 80 million records</a:t>
+                      </a:r>
+                    </a:p>
+                  </a:txBody>
+                  <a:tcPr/>
+                </a:tc>
+                <a:tc>
+                  <a:txBody>
+                    <a:bodyPr/>
+                    <a:lstStyle/>
+                    <a:p>
+                      <a:r>
+                        <a:rPr lang="en-GB" sz="1200" dirty="0"/>
+                        <a:t>5 minutes</a:t>
+                      </a:r>
+                    </a:p>
+                  </a:txBody>
+                  <a:tcPr/>
+                </a:tc>
+                <a:tc>
+                  <a:txBody>
+                    <a:bodyPr/>
+                    <a:lstStyle/>
+                    <a:p>
+                      <a:r>
+                        <a:rPr lang="en-GB" sz="1200" dirty="0"/>
+                        <a:t>8 minutes</a:t>
+                      </a:r>
+                    </a:p>
+                  </a:txBody>
+                  <a:tcPr/>
+                </a:tc>
+                <a:tc>
+                  <a:txBody>
+                    <a:bodyPr/>
+                    <a:lstStyle/>
+                    <a:p>
+                      <a:r>
+                        <a:rPr lang="en-GB" sz="1200" dirty="0"/>
+                        <a:t>15 minutes</a:t>
+                      </a:r>
+                    </a:p>
+                  </a:txBody>
+                  <a:tcPr/>
+                </a:tc>
+                <a:tc>
+                  <a:txBody>
+                    <a:bodyPr/>
+                    <a:lstStyle/>
+                    <a:p>
+                      <a:r>
+                        <a:rPr lang="en-GB" sz="1200" dirty="0"/>
+                        <a:t>10 minutes</a:t>
+                      </a:r>
+                    </a:p>
+                  </a:txBody>
+                  <a:tcPr/>
+                </a:tc>
+              </a:tr>
+              <a:tr h="450000">
+                <a:tc>
+                  <a:txBody>
+                    <a:bodyPr/>
+                    <a:lstStyle/>
+                    <a:p>
+                      <a:r>
+                        <a:rPr lang="en-GB" sz="1200" dirty="0"/>
+                        <a:t>CyberArk integration and password rotation</a:t>
+                      </a:r>
+                    </a:p>
+                  </a:txBody>
+                  <a:tcPr/>
+                </a:tc>
+                <a:tc>
+                  <a:txBody>
+                    <a:bodyPr/>
+                    <a:lstStyle/>
+                    <a:p>
+                      <a:r>
+                        <a:rPr lang="en-GB" sz="1200" dirty="0"/>
+                        <a:t>validated</a:t>
+                      </a:r>
+                    </a:p>
+                  </a:txBody>
+                  <a:tcPr/>
+                </a:tc>
+                <a:tc>
+                  <a:txBody>
+                    <a:bodyPr/>
+                    <a:lstStyle/>
+                    <a:p>
+                      <a:r>
+                        <a:rPr lang="en-GB" sz="1200" dirty="0"/>
+                        <a:t>validated</a:t>
+                      </a:r>
+                    </a:p>
+                  </a:txBody>
+                  <a:tcPr/>
+                </a:tc>
+                <a:tc>
+                  <a:txBody>
+                    <a:bodyPr/>
+                    <a:lstStyle/>
+                    <a:p>
+                      <a:r>
+                        <a:rPr lang="en-GB" sz="1200" dirty="0"/>
+                        <a:t>issues identified</a:t>
+                      </a:r>
+                    </a:p>
+                  </a:txBody>
+                  <a:tcPr/>
+                </a:tc>
+                <a:tc>
+                  <a:txBody>
+                    <a:bodyPr/>
+                    <a:lstStyle/>
+                    <a:p>
+                      <a:r>
+                        <a:rPr lang="en-GB" sz="1200" dirty="0"/>
+                        <a:t>not verified</a:t>
+                      </a:r>
+                    </a:p>
+                  </a:txBody>
+                  <a:tcPr/>
+                </a:tc>
+              </a:tr>
+            </a:tbl>
+          </a:graphicData>
+        </a:graphic>
+      </p:graphicFrame>
+    </p:spTree>
+    <p:extLst>
+      <p:ext uri="{BB962C8B-B14F-4D97-AF65-F5344CB8AC3E}">
+        <p14:creationId xmlns:p14="http://schemas.microsoft.com/office/powerpoint/2010/main" val="1100000106"/>
+      </p:ext>
+    </p:extLst>
+  </p:cSld>
+  <p:clrMapOvr>
+    <a:masterClrMapping/>
+  </p:clrMapOvr>
+</p:sld>
+</file>
+
+<file path=ppt/slides/slide107.xml><?xml version="1.0" encoding="utf-8"?>
+<p:sld xmlns:a="http://schemas.openxmlformats.org/drawingml/2006/main" xmlns:r="http://schemas.openxmlformats.org/officeDocument/2006/relationships" xmlns:p="http://schemas.openxmlformats.org/presentationml/2006/main">
+  <p:cSld>
+    <p:spTree>
+      <p:nvGrpSpPr>
+        <p:cNvPr id="1" name=""/>
+        <p:cNvGrpSpPr/>
+        <p:nvPr/>
+      </p:nvGrpSpPr>
+      <p:grpSpPr>
+        <a:xfrm>
+          <a:off x="0" y="0"/>
+          <a:ext cx="0" cy="0"/>
+          <a:chOff x="0" y="0"/>
+          <a:chExt cx="0" cy="0"/>
+        </a:xfrm>
+      </p:grpSpPr>
+      <p:sp>
+        <p:nvSpPr>
+          <p:cNvPr id="2" name="Slide Number Placeholder"/>
+          <p:cNvSpPr>
+            <a:spLocks noGrp="1"/>
+          </p:cNvSpPr>
+          <p:nvPr>
+            <p:ph type="sldNum" sz="quarter" idx="12"/>
+          </p:nvPr>
+        </p:nvSpPr>
+        <p:spPr/>
+        <p:txBody>
+          <a:bodyPr/>
+          <a:lstStyle/>
+          <a:p>
+            <a:fld id="{5AF2E7C1-CA82-F241-8934-AACDE30393F4}" type="slidenum">
+              <a:rPr lang="en-GB" smtClean="0"/>
+              <a:pPr/>
+              <a:t>13</a:t>
+            </a:fld>
+            <a:endParaRPr lang="en-GB" dirty="0"/>
+          </a:p>
+        </p:txBody>
+      </p:sp>
+      <p:sp>
+        <p:nvSpPr>
+          <p:cNvPr id="3" name="Title Placeholder"/>
+          <p:cNvSpPr>
+            <a:spLocks noGrp="1"/>
+          </p:cNvSpPr>
+          <p:nvPr>
+            <p:ph type="body" sz="quarter" idx="13"/>
+          </p:nvPr>
+        </p:nvSpPr>
+        <p:spPr/>
+        <p:txBody>
+          <a:bodyPr/>
+          <a:lstStyle/>
+          <a:p>
+            <a:pPr lvl="0"/>
+            <a:r>
+              <a:rPr lang="en-GB" dirty="0"/>
+              <a:t>Airflow to Kubernetes via REST API</a:t>
+            </a:r>
+          </a:p>
+        </p:txBody>
+      </p:sp>
+      <p:sp>
+        <p:nvSpPr>
+          <p:cNvPr id="4" name="Subtitle Placeholder"/>
+          <p:cNvSpPr>
+            <a:spLocks noGrp="1"/>
+          </p:cNvSpPr>
+          <p:nvPr>
+            <p:ph type="body" sz="quarter" idx="14"/>
+          </p:nvPr>
+        </p:nvSpPr>
+        <p:spPr/>
+        <p:txBody>
+          <a:bodyPr/>
+          <a:lstStyle/>
+          <a:p>
+            <a:pPr lvl="0"/>
+            <a:r>
+              <a:rPr lang="en-GB" dirty="0"/>
+              <a:t>A standard, reusable integration pattern</a:t>
+            </a:r>
+          </a:p>
+        </p:txBody>
+      </p:sp>
+      <p:sp>
+        <p:nvSpPr>
+          <p:cNvPr id="5" name="Footer Placeholder"/>
+          <p:cNvSpPr>
+            <a:spLocks noGrp="1"/>
+          </p:cNvSpPr>
+          <p:nvPr>
+            <p:ph type="ftr" sz="quarter" idx="15"/>
+          </p:nvPr>
+        </p:nvSpPr>
+        <p:spPr/>
+        <p:txBody>
+          <a:bodyPr/>
+          <a:lstStyle/>
+          <a:p>
+            <a:r>
+              <a:rPr lang="en-GB"/>
+              <a:t>PPT Template 2.0</a:t>
+            </a:r>
+            <a:endParaRPr lang="en-GB" dirty="0"/>
+          </a:p>
+        </p:txBody>
+      </p:sp>
+      <p:sp>
+        <p:nvSpPr>
+          <p:cNvPr id="6" name="Body Left Placeholder"/>
+          <p:cNvSpPr>
+            <a:spLocks noGrp="1"/>
+          </p:cNvSpPr>
+          <p:nvPr>
+            <p:ph type="body" sz="quarter" idx="16"/>
+          </p:nvPr>
+        </p:nvSpPr>
+        <p:spPr/>
+        <p:txBody>
+          <a:bodyPr>
+            <a:normAutofit/>
+          </a:bodyPr>
+          <a:lstStyle/>
+          <a:p>
+            <a:pPr lvl="4"/>
+            <a:r>
+              <a:rPr lang="en-GB" dirty="0"/>
+              <a:t>Airflow’s KubernetesPodOperator communicates with the Kubernetes API server using a standard REST API</a:t>
+            </a:r>
+          </a:p>
+          <a:p>
+            <a:pPr lvl="4"/>
+            <a:r>
+              <a:rPr lang="en-GB" dirty="0"/>
+              <a:t>The connection between SOGE Airflow and Kubernetes in the KB environment is implemented purely as HTTPS REST calls, with no special protocol required</a:t>
+            </a:r>
+          </a:p>
+          <a:p>
+            <a:pPr lvl="4"/>
+            <a:r>
+              <a:rPr lang="en-GB" dirty="0"/>
+              <a:t>HTTPS REST API should already be permitted on the network pass-throughs between SOGE and KB</a:t>
+            </a:r>
+          </a:p>
+          <a:p>
+            <a:pPr lvl="4"/>
+            <a:r>
+              <a:rPr lang="en-GB" dirty="0"/>
+              <a:t>Security is generally favorable toward REST API</a:t>
+            </a:r>
+          </a:p>
+          <a:p>
+            <a:pPr lvl="4"/>
+            <a:r>
+              <a:rPr lang="en-GB" dirty="0"/>
+              <a:t>This could become a general pattern for connecting SOGE Airflow with the KB environment</a:t>
+            </a:r>
+          </a:p>
+        </p:txBody>
+      </p:sp>
+      <p:sp>
+        <p:nvSpPr>
+          <p:cNvPr id="7" name="Code Card"/>
+          <p:cNvSpPr/>
+          <p:nvPr/>
+        </p:nvSpPr>
+        <p:spPr>
+          <a:xfrm>
+            <a:off x="6173167" y="1109013"/>
+            <a:ext cx="5715000" cy="4200000"/>
+          </a:xfrm>
+          <a:prstGeom prst="roundRect">
+            <a:avLst>
+              <a:gd name="adj" fmla="val 4281"/>
+            </a:avLst>
+          </a:prstGeom>
+          <a:solidFill>
+            <a:srgbClr val="F5F5F5"/>
+          </a:solidFill>
+          <a:ln>
+            <a:solidFill>
+              <a:srgbClr val="D9D9D9"/>
+            </a:solidFill>
+          </a:ln>
+        </p:spPr>
+        <p:txBody>
+          <a:bodyPr wrap="square" lIns="180000" tIns="180000" rIns="180000" bIns="180000" anchor="t">
+            <a:normAutofit/>
+          </a:bodyPr>
+          <a:lstStyle/>
+          <a:p>
+            <a:pPr>
+              <a:buNone/>
+            </a:pPr>
+            <a:r>
+              <a:rPr lang="en-GB" sz="1050" dirty="0">
+                <a:latin typeface="Consolas" panose="020B0609020204030204" pitchFamily="49" charset="0"/>
+                <a:cs typeface="Consolas" panose="020B0609020204030204" pitchFamily="49" charset="0"/>
+              </a:rPr>
+              <a:t>from airflow.providers.cncf.kubernetes.operators.pod \</a:t>
+            </a:r>
+          </a:p>
+          <a:p>
+            <a:pPr>
+              <a:buNone/>
+            </a:pPr>
+            <a:r>
+              <a:rPr lang="en-GB" sz="1050" dirty="0">
+                <a:latin typeface="Consolas" panose="020B0609020204030204" pitchFamily="49" charset="0"/>
+                <a:cs typeface="Consolas" panose="020B0609020204030204" pitchFamily="49" charset="0"/>
+              </a:rPr>
+              <a:t>    import KubernetesPodOperator</a:t>
+            </a:r>
+          </a:p>
+          <a:p>
+            <a:pPr>
+              <a:buNone/>
+            </a:pPr>
+            <a:endParaRPr lang="en-GB" sz="1050" dirty="0">
+              <a:latin typeface="Consolas" panose="020B0609020204030204" pitchFamily="49" charset="0"/>
+              <a:cs typeface="Consolas" panose="020B0609020204030204" pitchFamily="49" charset="0"/>
+            </a:endParaRPr>
+          </a:p>
+          <a:p>
+            <a:pPr>
+              <a:buNone/>
+            </a:pPr>
+            <a:r>
+              <a:rPr lang="en-GB" sz="1050" dirty="0">
+                <a:latin typeface="Consolas" panose="020B0609020204030204" pitchFamily="49" charset="0"/>
+                <a:cs typeface="Consolas" panose="020B0609020204030204" pitchFamily="49" charset="0"/>
+              </a:rPr>
+              <a:t>run_minifi = KubernetesPodOperator(</a:t>
+            </a:r>
+          </a:p>
+          <a:p>
+            <a:pPr>
+              <a:buNone/>
+            </a:pPr>
+            <a:r>
+              <a:rPr lang="en-GB" sz="1050" dirty="0">
+                <a:latin typeface="Consolas" panose="020B0609020204030204" pitchFamily="49" charset="0"/>
+                <a:cs typeface="Consolas" panose="020B0609020204030204" pitchFamily="49" charset="0"/>
+              </a:rPr>
+              <a:t>    task_id="run_minifi_crm_export",</a:t>
+            </a:r>
+          </a:p>
+          <a:p>
+            <a:pPr>
+              <a:buNone/>
+            </a:pPr>
+            <a:r>
+              <a:rPr lang="en-GB" sz="1050" dirty="0">
+                <a:latin typeface="Consolas" panose="020B0609020204030204" pitchFamily="49" charset="0"/>
+                <a:cs typeface="Consolas" panose="020B0609020204030204" pitchFamily="49" charset="0"/>
+              </a:rPr>
+              <a:t>    namespace="crm-squad-ns",</a:t>
+            </a:r>
+          </a:p>
+          <a:p>
+            <a:pPr>
+              <a:buNone/>
+            </a:pPr>
+            <a:r>
+              <a:rPr lang="en-GB" sz="1050" dirty="0">
+                <a:latin typeface="Consolas" panose="020B0609020204030204" pitchFamily="49" charset="0"/>
+                <a:cs typeface="Consolas" panose="020B0609020204030204" pitchFamily="49" charset="0"/>
+              </a:rPr>
+              <a:t>    image="harbor.kb.cz/minifi/minifi-template:1.4.0",</a:t>
+            </a:r>
+          </a:p>
+          <a:p>
+            <a:pPr>
+              <a:buNone/>
+            </a:pPr>
+            <a:r>
+              <a:rPr lang="en-GB" sz="1050" dirty="0">
+                <a:latin typeface="Consolas" panose="020B0609020204030204" pitchFamily="49" charset="0"/>
+                <a:cs typeface="Consolas" panose="020B0609020204030204" pitchFamily="49" charset="0"/>
+              </a:rPr>
+              <a:t>    cmds=["/opt/minifi/bin/run.sh"],</a:t>
+            </a:r>
+          </a:p>
+          <a:p>
+            <a:pPr>
+              <a:buNone/>
+            </a:pPr>
+            <a:r>
+              <a:rPr lang="en-GB" sz="1050" dirty="0">
+                <a:latin typeface="Consolas" panose="020B0609020204030204" pitchFamily="49" charset="0"/>
+                <a:cs typeface="Consolas" panose="020B0609020204030204" pitchFamily="49" charset="0"/>
+              </a:rPr>
+              <a:t>    arguments=["--config", "/config/exports.yaml"],</a:t>
+            </a:r>
+          </a:p>
+          <a:p>
+            <a:pPr>
+              <a:buNone/>
+            </a:pPr>
+            <a:r>
+              <a:rPr lang="en-GB" sz="1050" dirty="0">
+                <a:latin typeface="Consolas" panose="020B0609020204030204" pitchFamily="49" charset="0"/>
+                <a:cs typeface="Consolas" panose="020B0609020204030204" pitchFamily="49" charset="0"/>
+              </a:rPr>
+              <a:t>    kubernetes_conn_id="kb_onprem_k8s",</a:t>
+            </a:r>
+          </a:p>
+          <a:p>
+            <a:pPr>
+              <a:buNone/>
+            </a:pPr>
+            <a:r>
+              <a:rPr lang="en-GB" sz="1050" dirty="0">
+                <a:latin typeface="Consolas" panose="020B0609020204030204" pitchFamily="49" charset="0"/>
+                <a:cs typeface="Consolas" panose="020B0609020204030204" pitchFamily="49" charset="0"/>
+              </a:rPr>
+              <a:t>    get_logs=True,</a:t>
+            </a:r>
+          </a:p>
+          <a:p>
+            <a:pPr>
+              <a:buNone/>
+            </a:pPr>
+            <a:r>
+              <a:rPr lang="en-GB" sz="1050" dirty="0">
+                <a:latin typeface="Consolas" panose="020B0609020204030204" pitchFamily="49" charset="0"/>
+                <a:cs typeface="Consolas" panose="020B0609020204030204" pitchFamily="49" charset="0"/>
+              </a:rPr>
+              <a:t>    is_delete_operator_pod=True,</a:t>
+            </a:r>
+          </a:p>
+          <a:p>
+            <a:pPr>
+              <a:buNone/>
+            </a:pPr>
+            <a:r>
+              <a:rPr lang="en-GB" sz="1050" dirty="0">
+                <a:latin typeface="Consolas" panose="020B0609020204030204" pitchFamily="49" charset="0"/>
+                <a:cs typeface="Consolas" panose="020B0609020204030204" pitchFamily="49" charset="0"/>
+              </a:rPr>
+              <a:t>)</a:t>
+            </a:r>
+          </a:p>
+        </p:txBody>
+      </p:sp>
+      <p:sp>
+        <p:nvSpPr>
+          <p:cNvPr id="8" name="Live Demo Note"/>
+          <p:cNvSpPr txBox="1"/>
+          <p:nvPr/>
+        </p:nvSpPr>
+        <p:spPr>
+          <a:xfrm>
+            <a:off x="6173167" y="5400000"/>
+            <a:ext cx="5715000" cy="650000"/>
+          </a:xfrm>
+          <a:prstGeom prst="rect">
+            <a:avLst/>
+          </a:prstGeom>
+        </p:spPr>
+        <p:txBody>
+          <a:bodyPr wrap="square">
+            <a:normAutofit/>
+          </a:bodyPr>
+          <a:lstStyle/>
+          <a:p>
+            <a:r>
+              <a:rPr lang="en-GB" sz="1200" i="1" dirty="0"/>
+              <a:t>Live demo: a real DAG will be run in Airflow to show a task spinning up a pod in Kubernetes.</a:t>
+            </a:r>
+          </a:p>
+        </p:txBody>
+      </p:sp>
+    </p:spTree>
+    <p:extLst>
+      <p:ext uri="{BB962C8B-B14F-4D97-AF65-F5344CB8AC3E}">
+        <p14:creationId xmlns:p14="http://schemas.microsoft.com/office/powerpoint/2010/main" val="1100000107"/>
+      </p:ext>
+    </p:extLst>
+  </p:cSld>
+  <p:clrMapOvr>
+    <a:masterClrMapping/>
+  </p:clrMapOvr>
+</p:sld>
+</file>
+
+<file path=ppt/slides/slide108.xml><?xml version="1.0" encoding="utf-8"?>
+<p:sld xmlns:a="http://schemas.openxmlformats.org/drawingml/2006/main" xmlns:r="http://schemas.openxmlformats.org/officeDocument/2006/relationships" xmlns:p="http://schemas.openxmlformats.org/presentationml/2006/main">
+  <p:cSld>
+    <p:spTree>
+      <p:nvGrpSpPr>
+        <p:cNvPr id="1" name=""/>
+        <p:cNvGrpSpPr/>
+        <p:nvPr/>
+      </p:nvGrpSpPr>
+      <p:grpSpPr>
+        <a:xfrm>
+          <a:off x="0" y="0"/>
+          <a:ext cx="0" cy="0"/>
+          <a:chOff x="0" y="0"/>
+          <a:chExt cx="0" cy="0"/>
+        </a:xfrm>
+      </p:grpSpPr>
+      <p:sp>
+        <p:nvSpPr>
+          <p:cNvPr id="2" name="Slide Number Placeholder"/>
+          <p:cNvSpPr>
+            <a:spLocks noGrp="1"/>
+          </p:cNvSpPr>
+          <p:nvPr>
+            <p:ph type="sldNum" sz="quarter" idx="12"/>
+          </p:nvPr>
+        </p:nvSpPr>
+        <p:spPr/>
+        <p:txBody>
+          <a:bodyPr/>
+          <a:lstStyle/>
+          <a:p>
+            <a:fld id="{5AF2E7C1-CA82-F241-8934-AACDE30393F4}" type="slidenum">
+              <a:rPr lang="en-GB" smtClean="0"/>
+              <a:pPr/>
+              <a:t>20</a:t>
+            </a:fld>
+            <a:endParaRPr lang="en-GB" dirty="0"/>
+          </a:p>
+        </p:txBody>
+      </p:sp>
+      <p:sp>
+        <p:nvSpPr>
+          <p:cNvPr id="3" name="Title Placeholder"/>
+          <p:cNvSpPr>
+            <a:spLocks noGrp="1"/>
+          </p:cNvSpPr>
+          <p:nvPr>
+            <p:ph type="body" sz="quarter" idx="13"/>
+          </p:nvPr>
+        </p:nvSpPr>
+        <p:spPr/>
+        <p:txBody>
+          <a:bodyPr/>
+          <a:lstStyle/>
+          <a:p>
+            <a:pPr lvl="0"/>
+            <a:r>
+              <a:rPr lang="en-GB" dirty="0"/>
+              <a:t>Recommendation</a:t>
+            </a:r>
+          </a:p>
+        </p:txBody>
+      </p:sp>
+      <p:sp>
+        <p:nvSpPr>
+          <p:cNvPr id="4" name="Subtitle Placeholder"/>
+          <p:cNvSpPr>
+            <a:spLocks noGrp="1"/>
+          </p:cNvSpPr>
+          <p:nvPr>
+            <p:ph type="body" sz="quarter" idx="14"/>
+          </p:nvPr>
+        </p:nvSpPr>
+        <p:spPr/>
+        <p:txBody>
+          <a:bodyPr/>
+          <a:lstStyle/>
+          <a:p>
+            <a:pPr lvl="0"/>
+            <a:r>
+              <a:rPr lang="en-GB" dirty="0"/>
+              <a:t>Target tool and next step</a:t>
+            </a:r>
+          </a:p>
+        </p:txBody>
+      </p:sp>
+      <p:sp>
+        <p:nvSpPr>
+          <p:cNvPr id="5" name="Footer Placeholder"/>
+          <p:cNvSpPr>
+            <a:spLocks noGrp="1"/>
+          </p:cNvSpPr>
+          <p:nvPr>
+            <p:ph type="ftr" sz="quarter" idx="15"/>
+          </p:nvPr>
+        </p:nvSpPr>
+        <p:spPr/>
+        <p:txBody>
+          <a:bodyPr/>
+          <a:lstStyle/>
+          <a:p>
+            <a:r>
+              <a:rPr lang="en-GB"/>
+              <a:t>PPT Template 2.0</a:t>
+            </a:r>
+            <a:endParaRPr lang="en-GB" dirty="0"/>
+          </a:p>
+        </p:txBody>
+      </p:sp>
+      <p:sp>
+        <p:nvSpPr>
+          <p:cNvPr id="6" name="Body Left Placeholder"/>
+          <p:cNvSpPr>
+            <a:spLocks noGrp="1"/>
+          </p:cNvSpPr>
+          <p:nvPr>
+            <p:ph type="body" sz="quarter" idx="16"/>
+          </p:nvPr>
+        </p:nvSpPr>
+        <p:spPr/>
+        <p:txBody>
+          <a:bodyPr>
+            <a:normAutofit/>
+          </a:bodyPr>
+          <a:lstStyle/>
+          <a:p>
+            <a:pPr lvl="4"/>
+            <a:r>
+              <a:rPr lang="en-GB" b="1" dirty="0"/>
+              <a:t>Recommended tool: Apache MiNiFi (Java agent), run as a pod in Kubernetes, started per run from SOGE Airflow</a:t>
+            </a:r>
+            <a:r>
+              <a:rPr lang="en-GB" dirty="0"/>
+              <a:t> — replacing the previously recommended AirPy</a:t>
+            </a:r>
+          </a:p>
+          <a:p>
+            <a:pPr lvl="4"/>
+            <a:r>
+              <a:rPr lang="en-GB" dirty="0"/>
+              <a:t>A single tool for all sources, including Kafka and Elasticsearch — no combination of two tools</a:t>
+            </a:r>
+          </a:p>
+          <a:p>
+            <a:pPr lvl="4"/>
+            <a:r>
+              <a:rPr lang="en-GB" dirty="0"/>
+              <a:t>Ready-made components instead of a custom framework in Airflow</a:t>
+            </a:r>
+          </a:p>
+          <a:p>
+            <a:pPr lvl="4"/>
+            <a:r>
+              <a:rPr lang="en-GB" dirty="0"/>
+              <a:t>Best result in Functional Capabilities, strong CI/CD and Git integration</a:t>
+            </a:r>
+          </a:p>
+          <a:p>
+            <a:pPr lvl="4"/>
+            <a:r>
+              <a:rPr lang="en-GB" dirty="0"/>
+              <a:t>No licensing costs, good alignment with the target architecture (K8s, Airflow, S3, Versioned Template Library)</a:t>
+            </a:r>
+          </a:p>
+          <a:p>
+            <a:pPr lvl="4"/>
+            <a:r>
+              <a:rPr lang="en-GB" dirty="0"/>
+              <a:t>AirPy remains a technically strong alternative, or fallback option, should the open validation items not be fulfilled</a:t>
+            </a:r>
+          </a:p>
+          <a:p>
+            <a:pPr lvl="4"/>
+            <a:r>
+              <a:rPr lang="en-GB" b="1" dirty="0"/>
+              <a:t>Requested decision: approve MiNiFi as the target solution and proceed with validating the open items</a:t>
+            </a:r>
+          </a:p>
+        </p:txBody>
+      </p:sp>
+    </p:spTree>
+    <p:extLst>
+      <p:ext uri="{BB962C8B-B14F-4D97-AF65-F5344CB8AC3E}">
+        <p14:creationId xmlns:p14="http://schemas.microsoft.com/office/powerpoint/2010/main" val="1100000108"/>
+      </p:ext>
+    </p:extLst>
+  </p:cSld>
+  <p:clrMapOvr>
+    <a:masterClrMapping/>
+  </p:clrMapOvr>
+</p:sld>
+</file>
+
+<file path=ppt/slides/slide109.xml><?xml version="1.0" encoding="utf-8"?>
+<p:sld xmlns:a="http://schemas.openxmlformats.org/drawingml/2006/main" xmlns:r="http://schemas.openxmlformats.org/officeDocument/2006/relationships" xmlns:p="http://schemas.openxmlformats.org/presentationml/2006/main">
+  <p:cSld>
+    <p:spTree>
+      <p:nvGrpSpPr>
+        <p:cNvPr id="1" name=""/>
+        <p:cNvGrpSpPr/>
+        <p:nvPr/>
+      </p:nvGrpSpPr>
+      <p:grpSpPr>
+        <a:xfrm>
+          <a:off x="0" y="0"/>
+          <a:ext cx="0" cy="0"/>
+          <a:chOff x="0" y="0"/>
+          <a:chExt cx="0" cy="0"/>
+        </a:xfrm>
+      </p:grpSpPr>
+      <p:sp>
+        <p:nvSpPr>
+          <p:cNvPr id="2" name="Slide Number Placeholder"/>
+          <p:cNvSpPr>
+            <a:spLocks noGrp="1"/>
+          </p:cNvSpPr>
+          <p:nvPr>
+            <p:ph type="sldNum" sz="quarter" idx="12"/>
+          </p:nvPr>
+        </p:nvSpPr>
+        <p:spPr/>
+        <p:txBody>
+          <a:bodyPr/>
+          <a:lstStyle/>
+          <a:p>
+            <a:fld id="{5AF2E7C1-CA82-F241-8934-AACDE30393F4}" type="slidenum">
+              <a:rPr lang="en-GB" smtClean="0"/>
+              <a:pPr/>
+              <a:t>21</a:t>
+            </a:fld>
+            <a:endParaRPr lang="en-GB" dirty="0"/>
+          </a:p>
+        </p:txBody>
+      </p:sp>
+      <p:sp>
+        <p:nvSpPr>
+          <p:cNvPr id="3" name="Title Placeholder"/>
+          <p:cNvSpPr>
+            <a:spLocks noGrp="1"/>
+          </p:cNvSpPr>
+          <p:nvPr>
+            <p:ph type="body" sz="quarter" idx="13"/>
+          </p:nvPr>
+        </p:nvSpPr>
+        <p:spPr/>
+        <p:txBody>
+          <a:bodyPr/>
+          <a:lstStyle/>
+          <a:p>
+            <a:pPr lvl="0"/>
+            <a:r>
+              <a:rPr lang="en-GB" dirty="0"/>
+              <a:t>Planned Next Steps</a:t>
+            </a:r>
+          </a:p>
+        </p:txBody>
+      </p:sp>
+      <p:sp>
+        <p:nvSpPr>
+          <p:cNvPr id="4" name="Subtitle Placeholder"/>
+          <p:cNvSpPr>
+            <a:spLocks noGrp="1"/>
+          </p:cNvSpPr>
+          <p:nvPr>
+            <p:ph type="body" sz="quarter" idx="14"/>
+          </p:nvPr>
+        </p:nvSpPr>
+        <p:spPr/>
+        <p:txBody>
+          <a:bodyPr/>
+          <a:lstStyle/>
+          <a:p>
+            <a:pPr lvl="0"/>
+            <a:r>
+              <a:rPr lang="en-GB" dirty="0"/>
+              <a:t>From technical validation to a go/no-go decision</a:t>
+            </a:r>
+          </a:p>
+        </p:txBody>
+      </p:sp>
+      <p:sp>
+        <p:nvSpPr>
+          <p:cNvPr id="5" name="Footer Placeholder"/>
+          <p:cNvSpPr>
+            <a:spLocks noGrp="1"/>
+          </p:cNvSpPr>
+          <p:nvPr>
+            <p:ph type="ftr" sz="quarter" idx="15"/>
+          </p:nvPr>
+        </p:nvSpPr>
+        <p:spPr/>
+        <p:txBody>
+          <a:bodyPr/>
+          <a:lstStyle/>
+          <a:p>
+            <a:r>
+              <a:rPr lang="en-GB"/>
+              <a:t>PPT Template 2.0</a:t>
+            </a:r>
+            <a:endParaRPr lang="en-GB" dirty="0"/>
+          </a:p>
+        </p:txBody>
+      </p:sp>
+      <p:sp>
+        <p:nvSpPr>
+          <p:cNvPr id="6" name="Tile1 Body idx16"/>
+          <p:cNvSpPr>
+            <a:spLocks noGrp="1"/>
+          </p:cNvSpPr>
+          <p:nvPr>
+            <p:ph type="body" sz="quarter" idx="16"/>
+          </p:nvPr>
+        </p:nvSpPr>
+        <p:spPr/>
+        <p:txBody>
+          <a:bodyPr>
+            <a:normAutofit/>
+          </a:bodyPr>
+          <a:lstStyle/>
+          <a:p>
+            <a:pPr lvl="4"/>
+            <a:r>
+              <a:rPr lang="en-GB" dirty="0"/>
+              <a:t>CyberArk integration and password rotation (Airflow → Secret → env var)</a:t>
+            </a:r>
+          </a:p>
+          <a:p>
+            <a:pPr lvl="4"/>
+            <a:r>
+              <a:rPr lang="en-GB" dirty="0"/>
+              <a:t>Pod lifecycle (wrapper / NiFi Stateless) — reliable detection of run completion</a:t>
+            </a:r>
+          </a:p>
+          <a:p>
+            <a:pPr lvl="4"/>
+            <a:r>
+              <a:rPr lang="en-GB" dirty="0"/>
+              <a:t>Availability of processors (Parquet, Kafka, Elasticsearch, AWS/S3) in the MiNiFi Java distribution</a:t>
+            </a:r>
+          </a:p>
+        </p:txBody>
+      </p:sp>
+      <p:sp>
+        <p:nvSpPr>
+          <p:cNvPr id="7" name="Tile3 Body idx17"/>
+          <p:cNvSpPr>
+            <a:spLocks noGrp="1"/>
+          </p:cNvSpPr>
+          <p:nvPr>
+            <p:ph type="body" sz="quarter" idx="17"/>
+          </p:nvPr>
+        </p:nvSpPr>
+        <p:spPr/>
+        <p:txBody>
+          <a:bodyPr>
+            <a:normAutofit/>
+          </a:bodyPr>
+          <a:lstStyle/>
+          <a:p>
+            <a:pPr lvl="2"/>
+            <a:r>
+              <a:rPr lang="en-GB" dirty="0"/>
+              <a:t>Confirming compliance with the Société Générale Greenbook</a:t>
+            </a:r>
+          </a:p>
+          <a:p>
+            <a:pPr lvl="2"/>
+            <a:r>
+              <a:rPr lang="en-GB" dirty="0"/>
+              <a:t>Effort estimate in person-days (environment setup, upskilling, migration)</a:t>
+            </a:r>
+          </a:p>
+          <a:p>
+            <a:pPr lvl="2"/>
+            <a:r>
+              <a:rPr lang="en-GB" dirty="0"/>
+              <a:t>Squad onboarding process (namespace, ServiceAccount, Conjur) with the Platform team</a:t>
+            </a:r>
+          </a:p>
+        </p:txBody>
+      </p:sp>
+      <p:sp>
+        <p:nvSpPr>
+          <p:cNvPr id="8" name="Tile1 Header idx18"/>
+          <p:cNvSpPr>
+            <a:spLocks noGrp="1"/>
+          </p:cNvSpPr>
+          <p:nvPr>
+            <p:ph type="body" sz="quarter" idx="18"/>
+          </p:nvPr>
+        </p:nvSpPr>
+        <p:spPr/>
+        <p:txBody>
+          <a:bodyPr/>
+          <a:lstStyle/>
+          <a:p>
+            <a:pPr lvl="0"/>
+            <a:r>
+              <a:rPr lang="en-GB" dirty="0"/>
+              <a:t>Phase 1 — Technical Validation (PoC)</a:t>
+            </a:r>
+          </a:p>
+        </p:txBody>
+      </p:sp>
+      <p:sp>
+        <p:nvSpPr>
+          <p:cNvPr id="9" name="Tile3 Header idx19"/>
+          <p:cNvSpPr>
+            <a:spLocks noGrp="1"/>
+          </p:cNvSpPr>
+          <p:nvPr>
+            <p:ph type="body" sz="quarter" idx="19"/>
+          </p:nvPr>
+        </p:nvSpPr>
+        <p:spPr/>
+        <p:txBody>
+          <a:bodyPr/>
+          <a:lstStyle/>
+          <a:p>
+            <a:pPr lvl="0"/>
+            <a:r>
+              <a:rPr lang="en-GB" dirty="0"/>
+              <a:t>Phase 3 — Governance and Compliance</a:t>
+            </a:r>
+          </a:p>
+        </p:txBody>
+      </p:sp>
+      <p:sp>
+        <p:nvSpPr>
+          <p:cNvPr id="10" name="Tile2 Body idx20"/>
+          <p:cNvSpPr>
+            <a:spLocks noGrp="1"/>
+          </p:cNvSpPr>
+          <p:nvPr>
+            <p:ph type="body" sz="quarter" idx="20"/>
+          </p:nvPr>
+        </p:nvSpPr>
+        <p:spPr/>
+        <p:txBody>
+          <a:bodyPr>
+            <a:normAutofit/>
+          </a:bodyPr>
+          <a:lstStyle/>
+          <a:p>
+            <a:pPr lvl="4"/>
+            <a:r>
+              <a:rPr lang="en-GB" dirty="0"/>
+              <a:t>Testing on larger data volumes</a:t>
+            </a:r>
+          </a:p>
+          <a:p>
+            <a:pPr lvl="4"/>
+            <a:r>
+              <a:rPr lang="en-GB" dirty="0"/>
+              <a:t>Teradata connectivity and performance</a:t>
+            </a:r>
+          </a:p>
+          <a:p>
+            <a:pPr lvl="4"/>
+            <a:r>
+              <a:rPr lang="en-GB" dirty="0"/>
+              <a:t>Validating the execution granularity model (pod per flow vs. per object) in real operation</a:t>
+            </a:r>
+          </a:p>
+        </p:txBody>
+      </p:sp>
+      <p:sp>
+        <p:nvSpPr>
+          <p:cNvPr id="11" name="Tile4 Body idx21"/>
+          <p:cNvSpPr>
+            <a:spLocks noGrp="1"/>
+          </p:cNvSpPr>
+          <p:nvPr>
+            <p:ph type="body" sz="quarter" idx="21"/>
+          </p:nvPr>
+        </p:nvSpPr>
+        <p:spPr/>
+        <p:txBody>
+          <a:bodyPr>
+            <a:normAutofit/>
+          </a:bodyPr>
+          <a:lstStyle/>
+          <a:p>
+            <a:pPr lvl="2"/>
+            <a:r>
+              <a:rPr lang="en-GB" dirty="0"/>
+              <a:t>Summary of PoC results → go/no-go decision for full migration</a:t>
+            </a:r>
+          </a:p>
+        </p:txBody>
+      </p:sp>
+      <p:sp>
+        <p:nvSpPr>
+          <p:cNvPr id="12" name="Tile4 Header idx22"/>
+          <p:cNvSpPr>
+            <a:spLocks noGrp="1"/>
+          </p:cNvSpPr>
+          <p:nvPr>
+            <p:ph type="body" sz="quarter" idx="22"/>
+          </p:nvPr>
+        </p:nvSpPr>
+        <p:spPr/>
+        <p:txBody>
+          <a:bodyPr/>
+          <a:lstStyle/>
+          <a:p>
+            <a:pPr lvl="0"/>
+            <a:r>
+              <a:rPr lang="en-GB" dirty="0"/>
+              <a:t>Decision Checkpoint</a:t>
+            </a:r>
+          </a:p>
+        </p:txBody>
+      </p:sp>
+      <p:sp>
+        <p:nvSpPr>
+          <p:cNvPr id="13" name="Tile2 Header idx23"/>
+          <p:cNvSpPr>
+            <a:spLocks noGrp="1"/>
+          </p:cNvSpPr>
+          <p:nvPr>
+            <p:ph type="body" sz="quarter" idx="23"/>
+          </p:nvPr>
+        </p:nvSpPr>
+        <p:spPr/>
+        <p:txBody>
+          <a:bodyPr/>
+          <a:lstStyle/>
+          <a:p>
+            <a:pPr lvl="0"/>
+            <a:r>
+              <a:rPr lang="en-GB" dirty="0"/>
+              <a:t>Phase 2 — Performance and Scale</a:t>
+            </a:r>
+          </a:p>
+        </p:txBody>
+      </p:sp>
+    </p:spTree>
+    <p:extLst>
+      <p:ext uri="{BB962C8B-B14F-4D97-AF65-F5344CB8AC3E}">
+        <p14:creationId xmlns:p14="http://schemas.microsoft.com/office/powerpoint/2010/main" val="1100000109"/>
+      </p:ext>
+    </p:extLst>
+  </p:cSld>
+  <p:clrMapOvr>
+    <a:masterClrMapping/>
+  </p:clrMapOvr>
+</p:sld>
+</file>
+
 <file path=ppt/slides/slide11.xml><?xml version="1.0" encoding="utf-8"?>
 <p:sld xmlns:a="http://schemas.openxmlformats.org/drawingml/2006/main" xmlns:r="http://schemas.openxmlformats.org/officeDocument/2006/relationships" xmlns:p="http://schemas.openxmlformats.org/presentationml/2006/main">
   <p:cSld>
@@ -20876,11 +23703,11 @@
           <a:lstStyle/>
           <a:p>
             <a:fld id="{5AF2E7C1-CA82-F241-8934-AACDE30393F4}" type="slidenum">
-              <a:rPr lang="en-CZ" smtClean="0"/>
+              <a:rPr lang="en-GB" smtClean="0"/>
               <a:pPr/>
               <a:t>28</a:t>
             </a:fld>
-            <a:endParaRPr lang="en-CZ" dirty="0"/>
+            <a:endParaRPr lang="en-GB" dirty="0"/>
           </a:p>
         </p:txBody>
       </p:sp>
@@ -20902,7 +23729,7 @@
             <a:pPr lvl="0"/>
             <a:r>
               <a:rPr lang="en-GB" dirty="0"/>
-              <a:t>What is MiNiFi?</a:t>
+              <a:t>What is MiNiFi</a:t>
             </a:r>
           </a:p>
         </p:txBody>
@@ -20925,7 +23752,7 @@
             <a:pPr lvl="0"/>
             <a:r>
               <a:rPr lang="en-GB" dirty="0"/>
-              <a:t>A lightweight Apache NiFi agent for edge data collection</a:t>
+              <a:t>A lightweight agent built on the Apache NiFi platform</a:t>
             </a:r>
           </a:p>
         </p:txBody>
@@ -20949,7 +23776,7 @@
               <a:rPr lang="en-GB"/>
               <a:t>PPT Template 2.0</a:t>
             </a:r>
-            <a:endParaRPr lang="en-CZ" dirty="0"/>
+            <a:endParaRPr lang="en-GB" dirty="0"/>
           </a:p>
         </p:txBody>
       </p:sp>
@@ -20965,34 +23792,43 @@
         </p:nvSpPr>
         <p:spPr/>
         <p:txBody>
-          <a:bodyPr/>
+          <a:bodyPr>
+            <a:normAutofit/>
+          </a:bodyPr>
           <a:lstStyle/>
           <a:p>
             <a:pPr lvl="4"/>
             <a:r>
               <a:rPr lang="en-GB" dirty="0"/>
-              <a:t>Java-based agent, part of the Apache NiFi project</a:t>
+              <a:t>The tool exists in two variants: a Java agent and a C++ agent</a:t>
             </a:r>
           </a:p>
           <a:p>
             <a:pPr lvl="4"/>
             <a:r>
               <a:rPr lang="en-GB" dirty="0"/>
-              <a:t>Included in every NiFi release since NiFi 2.0</a:t>
+              <a:t>The proposed solution uses the Java agent — the C++ variant has no Parquet writer, which is a hard requirement</a:t>
             </a:r>
           </a:p>
           <a:p>
             <a:pPr lvl="4"/>
             <a:r>
               <a:rPr lang="en-GB" dirty="0"/>
-              <a:t>Runs the same processors as NiFi — same functional coverage</a:t>
+              <a:t>Included in every NiFi release since version 2.0</a:t>
             </a:r>
           </a:p>
           <a:p>
             <a:pPr lvl="4"/>
             <a:r>
               <a:rPr lang="en-GB" dirty="0"/>
-              <a:t>No web UI — the flow is a definition file, kept in Git</a:t>
+              <a:t>Uses the same processors as NiFi — identical functional scope</a:t>
+            </a:r>
+          </a:p>
+          <a:p>
+            <a:pPr lvl="4"/>
+            <a:r>
+              <a:rPr lang="en-GB" dirty="0"/>
+              <a:t>No web user interface — the flow definition is stored as a file in Git</a:t>
             </a:r>
           </a:p>
         </p:txBody>
@@ -21038,7 +23874,7 @@
           <a:bodyPr/>
           <a:lstStyle/>
           <a:p>
-            <a:endParaRPr lang="en-CZ"/>
+            <a:endParaRPr lang="en-GB"/>
           </a:p>
         </p:txBody>
       </p:sp>
@@ -21088,11 +23924,11 @@
           <a:lstStyle/>
           <a:p>
             <a:fld id="{5AF2E7C1-CA82-F241-8934-AACDE30393F4}" type="slidenum">
-              <a:rPr lang="en-CZ" smtClean="0"/>
+              <a:rPr lang="en-GB" smtClean="0"/>
               <a:pPr/>
               <a:t>29</a:t>
             </a:fld>
-            <a:endParaRPr lang="en-CZ" dirty="0"/>
+            <a:endParaRPr lang="en-GB" dirty="0"/>
           </a:p>
         </p:txBody>
       </p:sp>
@@ -21114,7 +23950,7 @@
             <a:pPr lvl="0"/>
             <a:r>
               <a:rPr lang="en-GB" dirty="0"/>
-              <a:t>Why MiNiFi fits our case</a:t>
+              <a:t>Why MiNiFi Fits Our Case</a:t>
             </a:r>
           </a:p>
         </p:txBody>
@@ -21137,7 +23973,7 @@
             <a:pPr lvl="0"/>
             <a:r>
               <a:rPr lang="en-GB" dirty="0"/>
-              <a:t>Ready-made components instead of custom code</a:t>
+              <a:t>Using ready-made components instead of custom development</a:t>
             </a:r>
           </a:p>
         </p:txBody>
@@ -21161,7 +23997,7 @@
               <a:rPr lang="en-GB"/>
               <a:t>PPT Template 2.0</a:t>
             </a:r>
-            <a:endParaRPr lang="en-CZ" dirty="0"/>
+            <a:endParaRPr lang="en-GB" dirty="0"/>
           </a:p>
         </p:txBody>
       </p:sp>
@@ -21190,7 +24026,7 @@
             <a:pPr lvl="4"/>
             <a:r>
               <a:rPr lang="en-GB" dirty="0"/>
-              <a:t>Incremental extraction built in</a:t>
+              <a:t>Incremental extraction support</a:t>
             </a:r>
           </a:p>
         </p:txBody>
@@ -21213,14 +24049,14 @@
             <a:pPr lvl="2"/>
             <a:r>
               <a:rPr lang="en-GB" dirty="0"/>
-              <a:t>Built-in Parquet reader and writer</a:t>
+              <a:t>Built-in support for reading and writing Parquet</a:t>
             </a:r>
           </a:p>
           <a:p>
             <a:pPr lvl="2"/>
             <a:r>
               <a:rPr lang="en-GB" dirty="0"/>
-              <a:t>Direct S3 read and write</a:t>
+              <a:t>Direct access to S3 storage</a:t>
             </a:r>
           </a:p>
         </p:txBody>
@@ -21266,7 +24102,7 @@
             <a:pPr lvl="0"/>
             <a:r>
               <a:rPr lang="en-GB" dirty="0"/>
-              <a:t>Parquet &amp; S3</a:t>
+              <a:t>Parquet and S3</a:t>
             </a:r>
           </a:p>
         </p:txBody>
@@ -21289,14 +24125,14 @@
             <a:pPr lvl="4"/>
             <a:r>
               <a:rPr lang="en-GB" dirty="0"/>
-              <a:t>Native processors for both</a:t>
+              <a:t>Native processors for both technologies</a:t>
             </a:r>
           </a:p>
           <a:p>
             <a:pPr lvl="4"/>
             <a:r>
               <a:rPr lang="en-GB" dirty="0"/>
-              <a:t>One tool instead of two (AirPy + NiFi)</a:t>
+              <a:t>One tool instead of combining AirPy and NiFi</a:t>
             </a:r>
           </a:p>
         </p:txBody>
@@ -21319,14 +24155,14 @@
             <a:pPr lvl="2"/>
             <a:r>
               <a:rPr lang="en-GB" dirty="0"/>
-              <a:t>Flow definition is a file, not a UI-only config</a:t>
+              <a:t>The flow definition is a file, not just a UI-only configuration</a:t>
             </a:r>
           </a:p>
           <a:p>
             <a:pPr lvl="2"/>
             <a:r>
               <a:rPr lang="en-GB" dirty="0"/>
-              <a:t>Versioned in Git, reviewed in pull requests</a:t>
+              <a:t>Versioned in Git, reviewed via pull requests</a:t>
             </a:r>
           </a:p>
         </p:txBody>
@@ -21349,7 +24185,7 @@
             <a:pPr lvl="0"/>
             <a:r>
               <a:rPr lang="en-GB" dirty="0"/>
-              <a:t>Flow as code</a:t>
+              <a:t>Flow as Code</a:t>
             </a:r>
           </a:p>
         </p:txBody>
@@ -21372,7 +24208,7 @@
             <a:pPr lvl="0"/>
             <a:r>
               <a:rPr lang="en-GB" dirty="0"/>
-              <a:t>Kafka &amp; Elasticsearch</a:t>
+              <a:t>Kafka and Elasticsearch</a:t>
             </a:r>
           </a:p>
         </p:txBody>

</xml_diff>